<commit_message>
MVP M1 (rules v0.3.0): 표 템플릿 2종 + 녹색 역할색 + 판형 예약
경영관리 보고장표 대비 1차 — 표가 없으면 장표가 안 만들어진다.

- perf_table(실적표)·compare_table(비교표) 신설, 공용 그리드 engine/lib/table.ts
  (직접 드로잉 — option_table 선례·render-qa 정합·role 착색 계약 유지, addTable 미채택)
- 관계어 17종: 계획 대비·달성률·계열사 트리거로 폼 스터디 후보 자동 편입
- colors.json ok/okBg 등재 (실물 승인 덱 유래 녹색 — 상태 지목, 파랑=주체와 구분)
- visual.json canvas 블록 + meta.layout 가드 (판형 정본화, A4는 백로그)
- 덱보드 SkGridTable 스케치, validP perfRow 검사(cells 열 수 일치)
- BACKLOG-v0.3.md: 실물급 4종 좌표 분해 기록 반입
- showcase 표 2장, neg-4(에러 3건 검출 확인), artifact:test 68건 통과,
  골든 재빌드 무회귀(경고 6건·텍스트 대조 기존과 동일), tsc·lint 통과

Co-Authored-By: Claude Fable 5 <noreply@anthropic.com>
Claude-Session: https://claude.ai/code/session_01CfEEmWc8fhMf5s8XFVMS9K
</commit_message>
<xml_diff>
--- a/ppt/decks/template-showcase/template-showcase.pptx
+++ b/ppt/decks/template-showcase/template-showcase.pptx
@@ -12,9 +12,11 @@
     <p:sldId id="260" r:id="rId6"/>
     <p:sldId id="261" r:id="rId7"/>
     <p:sldId id="262" r:id="rId8"/>
+    <p:sldId id="263" r:id="rId9"/>
+    <p:sldId id="264" r:id="rId10"/>
   </p:sldIdLst>
   <p:notesMasterIdLst>
-    <p:notesMasterId r:id="rId9"/>
+    <p:notesMasterId r:id="rId11"/>
   </p:notesMasterIdLst>
   <p:sldSz cx="12192000" cy="6858000"/>
   <p:notesSz cx="6858000" cy="12192000"/>
@@ -1078,6 +1080,182 @@
 </p:notes>
 </file>
 
+<file path=ppt/notesSlides/notesSlide8.xml><?xml version="1.0" encoding="utf-8"?>
+<p:notes xmlns:a="http://schemas.openxmlformats.org/drawingml/2006/main" xmlns:r="http://schemas.openxmlformats.org/officeDocument/2006/relationships" xmlns:p="http://schemas.openxmlformats.org/presentationml/2006/main">
+  <p:cSld>
+    <p:spTree>
+      <p:nvGrpSpPr>
+        <p:cNvPr id="1" name=""/>
+        <p:cNvGrpSpPr/>
+        <p:nvPr/>
+      </p:nvGrpSpPr>
+      <p:grpSpPr>
+        <a:xfrm>
+          <a:off x="0" y="0"/>
+          <a:ext cx="0" cy="0"/>
+          <a:chOff x="0" y="0"/>
+          <a:chExt cx="0" cy="0"/>
+        </a:xfrm>
+      </p:grpSpPr>
+      <p:sp>
+        <p:nvSpPr>
+          <p:cNvPr id="2" name="Slide Image Placeholder 1"/>
+          <p:cNvSpPr>
+            <a:spLocks noGrp="1" noRot="1" noChangeAspect="1"/>
+          </p:cNvSpPr>
+          <p:nvPr>
+            <p:ph type="sldImg"/>
+          </p:nvPr>
+        </p:nvSpPr>
+        <p:spPr/>
+      </p:sp>
+      <p:sp>
+        <p:nvSpPr>
+          <p:cNvPr id="3" name="Notes Placeholder 2"/>
+          <p:cNvSpPr>
+            <a:spLocks noGrp="1"/>
+          </p:cNvSpPr>
+          <p:nvPr>
+            <p:ph type="body" idx="1"/>
+          </p:nvPr>
+        </p:nvSpPr>
+        <p:spPr/>
+        <p:txBody>
+          <a:bodyPr/>
+          <a:lstStyle/>
+          <a:p>
+            <a:r>
+              <a:rPr lang="en-US" dirty="0"/>
+              <a:t>실적표 폼 시연 — 증감 착색은 셀 tone(ok/problem)만으로, 수치 표기는 입력 그대로.</a:t>
+            </a:r>
+            <a:endParaRPr lang="en-US" dirty="0"/>
+          </a:p>
+        </p:txBody>
+      </p:sp>
+      <p:sp>
+        <p:nvSpPr>
+          <p:cNvPr id="4" name="Slide Number Placeholder 3"/>
+          <p:cNvSpPr>
+            <a:spLocks noGrp="1"/>
+          </p:cNvSpPr>
+          <p:nvPr>
+            <p:ph type="sldNum" sz="quarter" idx="10"/>
+          </p:nvPr>
+        </p:nvSpPr>
+        <p:spPr/>
+        <p:txBody>
+          <a:bodyPr/>
+          <a:lstStyle/>
+          <a:p>
+            <a:fld id="{F7021451-1387-4CA6-816F-3879F97B5CBC}" type="slidenum">
+              <a:rPr lang="en-US"/>
+              <a:t>8</a:t>
+            </a:fld>
+            <a:endParaRPr lang="en-US"/>
+          </a:p>
+        </p:txBody>
+      </p:sp>
+    </p:spTree>
+    <p:extLst>
+      <p:ext uri="{BB962C8B-B14F-4D97-AF65-F5344CB8AC3E}">
+        <p14:creationId xmlns:p14="http://schemas.microsoft.com/office/powerpoint/2010/main" val="1024086991"/>
+      </p:ext>
+    </p:extLst>
+  </p:cSld>
+  <p:clrMapOvr>
+    <a:masterClrMapping/>
+  </p:clrMapOvr>
+</p:notes>
+</file>
+
+<file path=ppt/notesSlides/notesSlide9.xml><?xml version="1.0" encoding="utf-8"?>
+<p:notes xmlns:a="http://schemas.openxmlformats.org/drawingml/2006/main" xmlns:r="http://schemas.openxmlformats.org/officeDocument/2006/relationships" xmlns:p="http://schemas.openxmlformats.org/presentationml/2006/main">
+  <p:cSld>
+    <p:spTree>
+      <p:nvGrpSpPr>
+        <p:cNvPr id="1" name=""/>
+        <p:cNvGrpSpPr/>
+        <p:nvPr/>
+      </p:nvGrpSpPr>
+      <p:grpSpPr>
+        <a:xfrm>
+          <a:off x="0" y="0"/>
+          <a:ext cx="0" cy="0"/>
+          <a:chOff x="0" y="0"/>
+          <a:chExt cx="0" cy="0"/>
+        </a:xfrm>
+      </p:grpSpPr>
+      <p:sp>
+        <p:nvSpPr>
+          <p:cNvPr id="2" name="Slide Image Placeholder 1"/>
+          <p:cNvSpPr>
+            <a:spLocks noGrp="1" noRot="1" noChangeAspect="1"/>
+          </p:cNvSpPr>
+          <p:nvPr>
+            <p:ph type="sldImg"/>
+          </p:nvPr>
+        </p:nvSpPr>
+        <p:spPr/>
+      </p:sp>
+      <p:sp>
+        <p:nvSpPr>
+          <p:cNvPr id="3" name="Notes Placeholder 2"/>
+          <p:cNvSpPr>
+            <a:spLocks noGrp="1"/>
+          </p:cNvSpPr>
+          <p:nvPr>
+            <p:ph type="body" idx="1"/>
+          </p:nvPr>
+        </p:nvSpPr>
+        <p:spPr/>
+        <p:txBody>
+          <a:bodyPr/>
+          <a:lstStyle/>
+          <a:p>
+            <a:r>
+              <a:rPr lang="en-US" dirty="0"/>
+              <a:t>비교표 폼 시연 — hiCol로 당사 열 강조, 타사 수치는 공시 출처 확보 전 (예시).</a:t>
+            </a:r>
+            <a:endParaRPr lang="en-US" dirty="0"/>
+          </a:p>
+        </p:txBody>
+      </p:sp>
+      <p:sp>
+        <p:nvSpPr>
+          <p:cNvPr id="4" name="Slide Number Placeholder 3"/>
+          <p:cNvSpPr>
+            <a:spLocks noGrp="1"/>
+          </p:cNvSpPr>
+          <p:nvPr>
+            <p:ph type="sldNum" sz="quarter" idx="10"/>
+          </p:nvPr>
+        </p:nvSpPr>
+        <p:spPr/>
+        <p:txBody>
+          <a:bodyPr/>
+          <a:lstStyle/>
+          <a:p>
+            <a:fld id="{F7021451-1387-4CA6-816F-3879F97B5CBC}" type="slidenum">
+              <a:rPr lang="en-US"/>
+              <a:t>9</a:t>
+            </a:fld>
+            <a:endParaRPr lang="en-US"/>
+          </a:p>
+        </p:txBody>
+      </p:sp>
+    </p:spTree>
+    <p:extLst>
+      <p:ext uri="{BB962C8B-B14F-4D97-AF65-F5344CB8AC3E}">
+        <p14:creationId xmlns:p14="http://schemas.microsoft.com/office/powerpoint/2010/main" val="1024086991"/>
+      </p:ext>
+    </p:extLst>
+  </p:cSld>
+  <p:clrMapOvr>
+    <a:masterClrMapping/>
+  </p:clrMapOvr>
+</p:notes>
+</file>
+
 <file path=ppt/slideLayouts/slideLayout1.xml><?xml version="1.0" encoding="utf-8"?>
 <p:sldLayout xmlns:a="http://schemas.openxmlformats.org/drawingml/2006/main" xmlns:r="http://schemas.openxmlformats.org/officeDocument/2006/relationships" xmlns:p="http://schemas.openxmlformats.org/presentationml/2006/main" preserve="1">
   <p:cSld name="DEFAULT">
@@ -7993,6 +8171,3572 @@
                 <a:cs typeface="맑은 고딕" pitchFamily="34" charset="-120"/>
               </a:rPr>
               <a:t>* 일정은 가정(예시), 확정 전</a:t>
+            </a:r>
+            <a:endParaRPr lang="en-US" sz="850" dirty="0"/>
+          </a:p>
+        </p:txBody>
+      </p:sp>
+    </p:spTree>
+  </p:cSld>
+  <p:clrMapOvr>
+    <a:masterClrMapping/>
+  </p:clrMapOvr>
+</p:sld>
+</file>
+
+<file path=ppt/slides/slide8.xml><?xml version="1.0" encoding="utf-8"?>
+<p:sld xmlns:a="http://schemas.openxmlformats.org/drawingml/2006/main" xmlns:r="http://schemas.openxmlformats.org/officeDocument/2006/relationships" xmlns:p="http://schemas.openxmlformats.org/presentationml/2006/main">
+  <p:cSld name="Slide 8">
+    <p:bg>
+      <p:bgPr>
+        <a:solidFill>
+          <a:srgbClr val="F2F4F7"/>
+        </a:solidFill>
+      </p:bgPr>
+    </p:bg>
+    <p:spTree>
+      <p:nvGrpSpPr>
+        <p:cNvPr id="1" name=""/>
+        <p:cNvGrpSpPr/>
+        <p:nvPr/>
+      </p:nvGrpSpPr>
+      <p:grpSpPr>
+        <a:xfrm>
+          <a:off x="0" y="0"/>
+          <a:ext cx="0" cy="0"/>
+          <a:chOff x="0" y="0"/>
+          <a:chExt cx="0" cy="0"/>
+        </a:xfrm>
+      </p:grpSpPr>
+      <p:sp>
+        <p:nvSpPr>
+          <p:cNvPr id="2" name="Text 0"/>
+          <p:cNvSpPr/>
+          <p:nvPr/>
+        </p:nvSpPr>
+        <p:spPr>
+          <a:xfrm>
+            <a:off x="365760" y="91440"/>
+            <a:ext cx="3657600" cy="201168"/>
+          </a:xfrm>
+          <a:prstGeom prst="rect">
+            <a:avLst/>
+          </a:prstGeom>
+          <a:noFill/>
+          <a:ln/>
+        </p:spPr>
+        <p:txBody>
+          <a:bodyPr wrap="square" lIns="0" tIns="0" rIns="0" bIns="0" rtlCol="0" anchor="ctr"/>
+          <a:lstStyle/>
+          <a:p>
+            <a:pPr algn="l" indent="0" marL="0">
+              <a:buNone/>
+            </a:pPr>
+            <a:r>
+              <a:rPr lang="en-US" sz="800" dirty="0">
+                <a:solidFill>
+                  <a:srgbClr val="8A93A4"/>
+                </a:solidFill>
+                <a:latin typeface="맑은 고딕" pitchFamily="34" charset="0"/>
+                <a:ea typeface="맑은 고딕" pitchFamily="34" charset="-122"/>
+                <a:cs typeface="맑은 고딕" pitchFamily="34" charset="-120"/>
+              </a:rPr>
+              <a:t>템플릿 쇼케이스</a:t>
+            </a:r>
+            <a:endParaRPr lang="en-US" sz="800" dirty="0"/>
+          </a:p>
+        </p:txBody>
+      </p:sp>
+      <p:sp>
+        <p:nvSpPr>
+          <p:cNvPr id="3" name="Text 1"/>
+          <p:cNvSpPr/>
+          <p:nvPr/>
+        </p:nvSpPr>
+        <p:spPr>
+          <a:xfrm>
+            <a:off x="365760" y="329184"/>
+            <a:ext cx="8778240" cy="512064"/>
+          </a:xfrm>
+          <a:prstGeom prst="rect">
+            <a:avLst/>
+          </a:prstGeom>
+          <a:noFill/>
+          <a:ln/>
+        </p:spPr>
+        <p:txBody>
+          <a:bodyPr wrap="square" lIns="0" tIns="0" rIns="0" bIns="0" rtlCol="0" anchor="ctr"/>
+          <a:lstStyle/>
+          <a:p>
+            <a:pPr algn="l" indent="0" marL="0">
+              <a:buNone/>
+            </a:pPr>
+            <a:r>
+              <a:rPr lang="en-US" sz="2700" b="1" dirty="0">
+                <a:solidFill>
+                  <a:srgbClr val="0F1E5A"/>
+                </a:solidFill>
+                <a:latin typeface="맑은 고딕" pitchFamily="34" charset="0"/>
+                <a:ea typeface="맑은 고딕" pitchFamily="34" charset="-122"/>
+                <a:cs typeface="맑은 고딕" pitchFamily="34" charset="-120"/>
+              </a:rPr>
+              <a:t>월간 실적</a:t>
+            </a:r>
+            <a:endParaRPr lang="en-US" sz="2700" dirty="0"/>
+          </a:p>
+        </p:txBody>
+      </p:sp>
+      <p:sp>
+        <p:nvSpPr>
+          <p:cNvPr id="4" name="Shape 2"/>
+          <p:cNvSpPr/>
+          <p:nvPr/>
+        </p:nvSpPr>
+        <p:spPr>
+          <a:xfrm>
+            <a:off x="9418320" y="402336"/>
+            <a:ext cx="2432304" cy="402336"/>
+          </a:xfrm>
+          <a:prstGeom prst="roundRect">
+            <a:avLst>
+              <a:gd name="adj" fmla="val 50000"/>
+            </a:avLst>
+          </a:prstGeom>
+          <a:solidFill>
+            <a:srgbClr val="4FC8DF"/>
+          </a:solidFill>
+          <a:ln/>
+        </p:spPr>
+      </p:sp>
+      <p:sp>
+        <p:nvSpPr>
+          <p:cNvPr id="5" name="Text 3"/>
+          <p:cNvSpPr/>
+          <p:nvPr/>
+        </p:nvSpPr>
+        <p:spPr>
+          <a:xfrm>
+            <a:off x="9418320" y="402336"/>
+            <a:ext cx="2432304" cy="402336"/>
+          </a:xfrm>
+          <a:prstGeom prst="rect">
+            <a:avLst/>
+          </a:prstGeom>
+          <a:noFill/>
+          <a:ln/>
+        </p:spPr>
+        <p:txBody>
+          <a:bodyPr wrap="square" lIns="0" tIns="0" rIns="0" bIns="0" rtlCol="0" anchor="ctr"/>
+          <a:lstStyle/>
+          <a:p>
+            <a:pPr algn="ctr" indent="0" marL="0">
+              <a:buNone/>
+            </a:pPr>
+            <a:r>
+              <a:rPr lang="en-US" sz="1300" b="1" dirty="0">
+                <a:solidFill>
+                  <a:srgbClr val="0F1E5A"/>
+                </a:solidFill>
+                <a:latin typeface="맑은 고딕" pitchFamily="34" charset="0"/>
+                <a:ea typeface="맑은 고딕" pitchFamily="34" charset="-122"/>
+                <a:cs typeface="맑은 고딕" pitchFamily="34" charset="-120"/>
+              </a:rPr>
+              <a:t>실적표</a:t>
+            </a:r>
+            <a:endParaRPr lang="en-US" sz="1300" dirty="0"/>
+          </a:p>
+        </p:txBody>
+      </p:sp>
+      <p:sp>
+        <p:nvSpPr>
+          <p:cNvPr id="6" name="Shape 4"/>
+          <p:cNvSpPr/>
+          <p:nvPr/>
+        </p:nvSpPr>
+        <p:spPr>
+          <a:xfrm>
+            <a:off x="329184" y="1005840"/>
+            <a:ext cx="11530584" cy="5541264"/>
+          </a:xfrm>
+          <a:prstGeom prst="roundRect">
+            <a:avLst>
+              <a:gd name="adj" fmla="val 990"/>
+            </a:avLst>
+          </a:prstGeom>
+          <a:solidFill>
+            <a:srgbClr val="FFFFFF"/>
+          </a:solidFill>
+          <a:ln w="12700">
+            <a:solidFill>
+              <a:srgbClr val="D8DDE6"/>
+            </a:solidFill>
+            <a:prstDash val="solid"/>
+          </a:ln>
+        </p:spPr>
+      </p:sp>
+      <p:sp>
+        <p:nvSpPr>
+          <p:cNvPr id="7" name="Text 5"/>
+          <p:cNvSpPr/>
+          <p:nvPr/>
+        </p:nvSpPr>
+        <p:spPr>
+          <a:xfrm>
+            <a:off x="11475720" y="6583680"/>
+            <a:ext cx="457200" cy="201168"/>
+          </a:xfrm>
+          <a:prstGeom prst="rect">
+            <a:avLst/>
+          </a:prstGeom>
+          <a:noFill/>
+          <a:ln/>
+        </p:spPr>
+        <p:txBody>
+          <a:bodyPr wrap="square" lIns="0" tIns="0" rIns="0" bIns="0" rtlCol="0" anchor="ctr"/>
+          <a:lstStyle/>
+          <a:p>
+            <a:pPr algn="r" indent="0" marL="0">
+              <a:buNone/>
+            </a:pPr>
+            <a:r>
+              <a:rPr lang="en-US" sz="900" dirty="0">
+                <a:solidFill>
+                  <a:srgbClr val="8A93A4"/>
+                </a:solidFill>
+                <a:latin typeface="맑은 고딕" pitchFamily="34" charset="0"/>
+                <a:ea typeface="맑은 고딕" pitchFamily="34" charset="-122"/>
+                <a:cs typeface="맑은 고딕" pitchFamily="34" charset="-120"/>
+              </a:rPr>
+              <a:t>8</a:t>
+            </a:r>
+            <a:endParaRPr lang="en-US" sz="900" dirty="0"/>
+          </a:p>
+        </p:txBody>
+      </p:sp>
+      <p:sp>
+        <p:nvSpPr>
+          <p:cNvPr id="8" name="Shape 6"/>
+          <p:cNvSpPr/>
+          <p:nvPr/>
+        </p:nvSpPr>
+        <p:spPr>
+          <a:xfrm>
+            <a:off x="658368" y="1243584"/>
+            <a:ext cx="64008" cy="457200"/>
+          </a:xfrm>
+          <a:prstGeom prst="rect">
+            <a:avLst/>
+          </a:prstGeom>
+          <a:solidFill>
+            <a:srgbClr val="0F1E5A"/>
+          </a:solidFill>
+          <a:ln/>
+        </p:spPr>
+      </p:sp>
+      <p:sp>
+        <p:nvSpPr>
+          <p:cNvPr id="9" name="Text 7"/>
+          <p:cNvSpPr/>
+          <p:nvPr/>
+        </p:nvSpPr>
+        <p:spPr>
+          <a:xfrm>
+            <a:off x="859536" y="1188720"/>
+            <a:ext cx="10607040" cy="548640"/>
+          </a:xfrm>
+          <a:prstGeom prst="rect">
+            <a:avLst/>
+          </a:prstGeom>
+          <a:noFill/>
+          <a:ln/>
+        </p:spPr>
+        <p:txBody>
+          <a:bodyPr wrap="square" lIns="0" tIns="0" rIns="0" bIns="0" rtlCol="0" anchor="ctr"/>
+          <a:lstStyle/>
+          <a:p>
+            <a:pPr algn="l" indent="0" marL="0">
+              <a:buNone/>
+            </a:pPr>
+            <a:r>
+              <a:rPr lang="en-US" sz="1900" b="1" dirty="0">
+                <a:solidFill>
+                  <a:srgbClr val="1F2A44"/>
+                </a:solidFill>
+                <a:latin typeface="맑은 고딕" pitchFamily="34" charset="0"/>
+                <a:ea typeface="맑은 고딕" pitchFamily="34" charset="-122"/>
+                <a:cs typeface="맑은 고딕" pitchFamily="34" charset="-120"/>
+              </a:rPr>
+              <a:t>핵심 지표 4개 중 3개가 계획을 </a:t>
+            </a:r>
+            <a:pPr algn="l" indent="0" marL="0">
+              <a:buNone/>
+            </a:pPr>
+            <a:r>
+              <a:rPr lang="en-US" sz="1900" b="1" dirty="0">
+                <a:solidFill>
+                  <a:srgbClr val="1F2A44"/>
+                </a:solidFill>
+                <a:highlight>
+                  <a:srgbClr val="FFF04D"/>
+                </a:highlight>
+                <a:latin typeface="맑은 고딕" pitchFamily="34" charset="0"/>
+                <a:ea typeface="맑은 고딕" pitchFamily="34" charset="-122"/>
+                <a:cs typeface="맑은 고딕" pitchFamily="34" charset="-120"/>
+              </a:rPr>
+              <a:t>초과 달성</a:t>
+            </a:r>
+            <a:pPr algn="l" indent="0" marL="0">
+              <a:buNone/>
+            </a:pPr>
+            <a:r>
+              <a:rPr lang="en-US" sz="1900" b="1" dirty="0">
+                <a:solidFill>
+                  <a:srgbClr val="1F2A44"/>
+                </a:solidFill>
+                <a:latin typeface="맑은 고딕" pitchFamily="34" charset="0"/>
+                <a:ea typeface="맑은 고딕" pitchFamily="34" charset="-122"/>
+                <a:cs typeface="맑은 고딕" pitchFamily="34" charset="-120"/>
+              </a:rPr>
+              <a:t>함</a:t>
+            </a:r>
+            <a:endParaRPr lang="en-US" sz="1900" dirty="0"/>
+          </a:p>
+        </p:txBody>
+      </p:sp>
+      <p:sp>
+        <p:nvSpPr>
+          <p:cNvPr id="10" name="Text 8"/>
+          <p:cNvSpPr/>
+          <p:nvPr/>
+        </p:nvSpPr>
+        <p:spPr>
+          <a:xfrm>
+            <a:off x="877824" y="1792224"/>
+            <a:ext cx="10515600" cy="274320"/>
+          </a:xfrm>
+          <a:prstGeom prst="rect">
+            <a:avLst/>
+          </a:prstGeom>
+          <a:noFill/>
+          <a:ln/>
+        </p:spPr>
+        <p:txBody>
+          <a:bodyPr wrap="square" lIns="0" tIns="0" rIns="0" bIns="0" rtlCol="0" anchor="ctr"/>
+          <a:lstStyle/>
+          <a:p>
+            <a:pPr algn="l" indent="0" marL="0">
+              <a:buNone/>
+            </a:pPr>
+            <a:r>
+              <a:rPr lang="en-US" sz="1300" dirty="0">
+                <a:solidFill>
+                  <a:srgbClr val="5A6472"/>
+                </a:solidFill>
+                <a:latin typeface="맑은 고딕" pitchFamily="34" charset="0"/>
+                <a:ea typeface="맑은 고딕" pitchFamily="34" charset="-122"/>
+                <a:cs typeface="맑은 고딕" pitchFamily="34" charset="-120"/>
+              </a:rPr>
+              <a:t>미달 1개(손해율)는 요인 분석 후 다음 달 대응 방향을 보고함</a:t>
+            </a:r>
+            <a:endParaRPr lang="en-US" sz="1300" dirty="0"/>
+          </a:p>
+        </p:txBody>
+      </p:sp>
+      <p:sp>
+        <p:nvSpPr>
+          <p:cNvPr id="11" name="Shape 9"/>
+          <p:cNvSpPr/>
+          <p:nvPr/>
+        </p:nvSpPr>
+        <p:spPr>
+          <a:xfrm>
+            <a:off x="658368" y="2267712"/>
+            <a:ext cx="10881360" cy="365760"/>
+          </a:xfrm>
+          <a:prstGeom prst="rect">
+            <a:avLst/>
+          </a:prstGeom>
+          <a:solidFill>
+            <a:srgbClr val="0F1E5A"/>
+          </a:solidFill>
+          <a:ln/>
+        </p:spPr>
+      </p:sp>
+      <p:sp>
+        <p:nvSpPr>
+          <p:cNvPr id="12" name="Text 10"/>
+          <p:cNvSpPr/>
+          <p:nvPr/>
+        </p:nvSpPr>
+        <p:spPr>
+          <a:xfrm>
+            <a:off x="658368" y="2267712"/>
+            <a:ext cx="10881360" cy="365760"/>
+          </a:xfrm>
+          <a:prstGeom prst="rect">
+            <a:avLst/>
+          </a:prstGeom>
+          <a:noFill/>
+          <a:ln/>
+        </p:spPr>
+        <p:txBody>
+          <a:bodyPr wrap="square" lIns="0" tIns="0" rIns="0" bIns="0" rtlCol="0" anchor="ctr"/>
+          <a:lstStyle/>
+          <a:p>
+            <a:pPr algn="ctr" indent="0" marL="0">
+              <a:buNone/>
+            </a:pPr>
+            <a:r>
+              <a:rPr lang="en-US" sz="1300" b="1" dirty="0">
+                <a:solidFill>
+                  <a:srgbClr val="FFFFFF"/>
+                </a:solidFill>
+                <a:latin typeface="맑은 고딕" pitchFamily="34" charset="0"/>
+                <a:ea typeface="맑은 고딕" pitchFamily="34" charset="-122"/>
+                <a:cs typeface="맑은 고딕" pitchFamily="34" charset="-120"/>
+              </a:rPr>
+              <a:t>월간 핵심 지표, 계획 대비 (예시)</a:t>
+            </a:r>
+            <a:endParaRPr lang="en-US" sz="1300" dirty="0"/>
+          </a:p>
+        </p:txBody>
+      </p:sp>
+      <p:sp>
+        <p:nvSpPr>
+          <p:cNvPr id="13" name="Text 11"/>
+          <p:cNvSpPr/>
+          <p:nvPr/>
+        </p:nvSpPr>
+        <p:spPr>
+          <a:xfrm>
+            <a:off x="658368" y="2468880"/>
+            <a:ext cx="10881360" cy="219456"/>
+          </a:xfrm>
+          <a:prstGeom prst="rect">
+            <a:avLst/>
+          </a:prstGeom>
+          <a:noFill/>
+          <a:ln/>
+        </p:spPr>
+        <p:txBody>
+          <a:bodyPr wrap="square" lIns="0" tIns="0" rIns="0" bIns="0" rtlCol="0" anchor="ctr"/>
+          <a:lstStyle/>
+          <a:p>
+            <a:pPr algn="r" indent="0" marL="0">
+              <a:buNone/>
+            </a:pPr>
+            <a:r>
+              <a:rPr lang="en-US" sz="950" dirty="0">
+                <a:solidFill>
+                  <a:srgbClr val="5A6472"/>
+                </a:solidFill>
+                <a:latin typeface="맑은 고딕" pitchFamily="34" charset="0"/>
+                <a:ea typeface="맑은 고딕" pitchFamily="34" charset="-122"/>
+                <a:cs typeface="맑은 고딕" pitchFamily="34" charset="-120"/>
+              </a:rPr>
+              <a:t>단위: 건·억원 (예시)</a:t>
+            </a:r>
+            <a:endParaRPr lang="en-US" sz="950" dirty="0"/>
+          </a:p>
+        </p:txBody>
+      </p:sp>
+      <p:sp>
+        <p:nvSpPr>
+          <p:cNvPr id="14" name="Shape 12"/>
+          <p:cNvSpPr/>
+          <p:nvPr/>
+        </p:nvSpPr>
+        <p:spPr>
+          <a:xfrm>
+            <a:off x="658368" y="2743200"/>
+            <a:ext cx="2377440" cy="457200"/>
+          </a:xfrm>
+          <a:prstGeom prst="rect">
+            <a:avLst/>
+          </a:prstGeom>
+          <a:solidFill>
+            <a:srgbClr val="0F1E5A"/>
+          </a:solidFill>
+          <a:ln w="9525">
+            <a:solidFill>
+              <a:srgbClr val="FFFFFF"/>
+            </a:solidFill>
+            <a:prstDash val="solid"/>
+          </a:ln>
+        </p:spPr>
+      </p:sp>
+      <p:sp>
+        <p:nvSpPr>
+          <p:cNvPr id="15" name="Text 13"/>
+          <p:cNvSpPr/>
+          <p:nvPr/>
+        </p:nvSpPr>
+        <p:spPr>
+          <a:xfrm>
+            <a:off x="658368" y="2743200"/>
+            <a:ext cx="2377440" cy="457200"/>
+          </a:xfrm>
+          <a:prstGeom prst="rect">
+            <a:avLst/>
+          </a:prstGeom>
+          <a:noFill/>
+          <a:ln/>
+        </p:spPr>
+        <p:txBody>
+          <a:bodyPr wrap="square" lIns="0" tIns="0" rIns="0" bIns="0" rtlCol="0" anchor="ctr"/>
+          <a:lstStyle/>
+          <a:p>
+            <a:pPr algn="ctr" indent="0" marL="0">
+              <a:buNone/>
+            </a:pPr>
+            <a:r>
+              <a:rPr lang="en-US" sz="1200" b="1" dirty="0">
+                <a:solidFill>
+                  <a:srgbClr val="FFFFFF"/>
+                </a:solidFill>
+                <a:latin typeface="맑은 고딕" pitchFamily="34" charset="0"/>
+                <a:ea typeface="맑은 고딕" pitchFamily="34" charset="-122"/>
+                <a:cs typeface="맑은 고딕" pitchFamily="34" charset="-120"/>
+              </a:rPr>
+              <a:t>지표</a:t>
+            </a:r>
+            <a:endParaRPr lang="en-US" sz="1200" dirty="0"/>
+          </a:p>
+        </p:txBody>
+      </p:sp>
+      <p:sp>
+        <p:nvSpPr>
+          <p:cNvPr id="16" name="Shape 14"/>
+          <p:cNvSpPr/>
+          <p:nvPr/>
+        </p:nvSpPr>
+        <p:spPr>
+          <a:xfrm>
+            <a:off x="3035808" y="2743200"/>
+            <a:ext cx="2834640" cy="457200"/>
+          </a:xfrm>
+          <a:prstGeom prst="rect">
+            <a:avLst/>
+          </a:prstGeom>
+          <a:solidFill>
+            <a:srgbClr val="0F1E5A"/>
+          </a:solidFill>
+          <a:ln w="9525">
+            <a:solidFill>
+              <a:srgbClr val="FFFFFF"/>
+            </a:solidFill>
+            <a:prstDash val="solid"/>
+          </a:ln>
+        </p:spPr>
+      </p:sp>
+      <p:sp>
+        <p:nvSpPr>
+          <p:cNvPr id="17" name="Text 15"/>
+          <p:cNvSpPr/>
+          <p:nvPr/>
+        </p:nvSpPr>
+        <p:spPr>
+          <a:xfrm>
+            <a:off x="3035808" y="2743200"/>
+            <a:ext cx="2834640" cy="457200"/>
+          </a:xfrm>
+          <a:prstGeom prst="rect">
+            <a:avLst/>
+          </a:prstGeom>
+          <a:noFill/>
+          <a:ln/>
+        </p:spPr>
+        <p:txBody>
+          <a:bodyPr wrap="square" lIns="0" tIns="0" rIns="0" bIns="0" rtlCol="0" anchor="ctr"/>
+          <a:lstStyle/>
+          <a:p>
+            <a:pPr algn="ctr" indent="0" marL="0">
+              <a:buNone/>
+            </a:pPr>
+            <a:r>
+              <a:rPr lang="en-US" sz="1150" b="1" dirty="0">
+                <a:solidFill>
+                  <a:srgbClr val="FFFFFF"/>
+                </a:solidFill>
+                <a:latin typeface="맑은 고딕" pitchFamily="34" charset="0"/>
+                <a:ea typeface="맑은 고딕" pitchFamily="34" charset="-122"/>
+                <a:cs typeface="맑은 고딕" pitchFamily="34" charset="-120"/>
+              </a:rPr>
+              <a:t>계획</a:t>
+            </a:r>
+            <a:endParaRPr lang="en-US" sz="1150" dirty="0"/>
+          </a:p>
+        </p:txBody>
+      </p:sp>
+      <p:sp>
+        <p:nvSpPr>
+          <p:cNvPr id="18" name="Shape 16"/>
+          <p:cNvSpPr/>
+          <p:nvPr/>
+        </p:nvSpPr>
+        <p:spPr>
+          <a:xfrm>
+            <a:off x="5870448" y="2743200"/>
+            <a:ext cx="2834640" cy="457200"/>
+          </a:xfrm>
+          <a:prstGeom prst="rect">
+            <a:avLst/>
+          </a:prstGeom>
+          <a:solidFill>
+            <a:srgbClr val="0F1E5A"/>
+          </a:solidFill>
+          <a:ln w="9525">
+            <a:solidFill>
+              <a:srgbClr val="FFFFFF"/>
+            </a:solidFill>
+            <a:prstDash val="solid"/>
+          </a:ln>
+        </p:spPr>
+      </p:sp>
+      <p:sp>
+        <p:nvSpPr>
+          <p:cNvPr id="19" name="Text 17"/>
+          <p:cNvSpPr/>
+          <p:nvPr/>
+        </p:nvSpPr>
+        <p:spPr>
+          <a:xfrm>
+            <a:off x="5870448" y="2743200"/>
+            <a:ext cx="2834640" cy="457200"/>
+          </a:xfrm>
+          <a:prstGeom prst="rect">
+            <a:avLst/>
+          </a:prstGeom>
+          <a:noFill/>
+          <a:ln/>
+        </p:spPr>
+        <p:txBody>
+          <a:bodyPr wrap="square" lIns="0" tIns="0" rIns="0" bIns="0" rtlCol="0" anchor="ctr"/>
+          <a:lstStyle/>
+          <a:p>
+            <a:pPr algn="ctr" indent="0" marL="0">
+              <a:buNone/>
+            </a:pPr>
+            <a:r>
+              <a:rPr lang="en-US" sz="1150" b="1" dirty="0">
+                <a:solidFill>
+                  <a:srgbClr val="FFFFFF"/>
+                </a:solidFill>
+                <a:latin typeface="맑은 고딕" pitchFamily="34" charset="0"/>
+                <a:ea typeface="맑은 고딕" pitchFamily="34" charset="-122"/>
+                <a:cs typeface="맑은 고딕" pitchFamily="34" charset="-120"/>
+              </a:rPr>
+              <a:t>실적</a:t>
+            </a:r>
+            <a:endParaRPr lang="en-US" sz="1150" dirty="0"/>
+          </a:p>
+        </p:txBody>
+      </p:sp>
+      <p:sp>
+        <p:nvSpPr>
+          <p:cNvPr id="20" name="Shape 18"/>
+          <p:cNvSpPr/>
+          <p:nvPr/>
+        </p:nvSpPr>
+        <p:spPr>
+          <a:xfrm>
+            <a:off x="8705088" y="2743200"/>
+            <a:ext cx="2834640" cy="457200"/>
+          </a:xfrm>
+          <a:prstGeom prst="rect">
+            <a:avLst/>
+          </a:prstGeom>
+          <a:solidFill>
+            <a:srgbClr val="0F1E5A"/>
+          </a:solidFill>
+          <a:ln w="9525">
+            <a:solidFill>
+              <a:srgbClr val="FFFFFF"/>
+            </a:solidFill>
+            <a:prstDash val="solid"/>
+          </a:ln>
+        </p:spPr>
+      </p:sp>
+      <p:sp>
+        <p:nvSpPr>
+          <p:cNvPr id="21" name="Text 19"/>
+          <p:cNvSpPr/>
+          <p:nvPr/>
+        </p:nvSpPr>
+        <p:spPr>
+          <a:xfrm>
+            <a:off x="8705088" y="2743200"/>
+            <a:ext cx="2834640" cy="457200"/>
+          </a:xfrm>
+          <a:prstGeom prst="rect">
+            <a:avLst/>
+          </a:prstGeom>
+          <a:noFill/>
+          <a:ln/>
+        </p:spPr>
+        <p:txBody>
+          <a:bodyPr wrap="square" lIns="0" tIns="0" rIns="0" bIns="0" rtlCol="0" anchor="ctr"/>
+          <a:lstStyle/>
+          <a:p>
+            <a:pPr algn="ctr" indent="0" marL="0">
+              <a:buNone/>
+            </a:pPr>
+            <a:r>
+              <a:rPr lang="en-US" sz="1150" b="1" dirty="0">
+                <a:solidFill>
+                  <a:srgbClr val="FFFFFF"/>
+                </a:solidFill>
+                <a:latin typeface="맑은 고딕" pitchFamily="34" charset="0"/>
+                <a:ea typeface="맑은 고딕" pitchFamily="34" charset="-122"/>
+                <a:cs typeface="맑은 고딕" pitchFamily="34" charset="-120"/>
+              </a:rPr>
+              <a:t>달성률</a:t>
+            </a:r>
+            <a:endParaRPr lang="en-US" sz="1150" dirty="0"/>
+          </a:p>
+        </p:txBody>
+      </p:sp>
+      <p:sp>
+        <p:nvSpPr>
+          <p:cNvPr id="22" name="Shape 20"/>
+          <p:cNvSpPr/>
+          <p:nvPr/>
+        </p:nvSpPr>
+        <p:spPr>
+          <a:xfrm>
+            <a:off x="658368" y="3200400"/>
+            <a:ext cx="2377440" cy="617220"/>
+          </a:xfrm>
+          <a:prstGeom prst="rect">
+            <a:avLst/>
+          </a:prstGeom>
+          <a:solidFill>
+            <a:srgbClr val="ECEFF3"/>
+          </a:solidFill>
+          <a:ln w="9525">
+            <a:solidFill>
+              <a:srgbClr val="D8DDE6"/>
+            </a:solidFill>
+            <a:prstDash val="solid"/>
+          </a:ln>
+        </p:spPr>
+      </p:sp>
+      <p:sp>
+        <p:nvSpPr>
+          <p:cNvPr id="23" name="Text 21"/>
+          <p:cNvSpPr/>
+          <p:nvPr/>
+        </p:nvSpPr>
+        <p:spPr>
+          <a:xfrm>
+            <a:off x="795528" y="3255264"/>
+            <a:ext cx="2103120" cy="308610"/>
+          </a:xfrm>
+          <a:prstGeom prst="rect">
+            <a:avLst/>
+          </a:prstGeom>
+          <a:noFill/>
+          <a:ln/>
+        </p:spPr>
+        <p:txBody>
+          <a:bodyPr wrap="square" lIns="0" tIns="0" rIns="0" bIns="0" rtlCol="0" anchor="ctr"/>
+          <a:lstStyle/>
+          <a:p>
+            <a:pPr algn="l" indent="0" marL="0">
+              <a:buNone/>
+            </a:pPr>
+            <a:r>
+              <a:rPr lang="en-US" sz="1200" b="1" dirty="0">
+                <a:solidFill>
+                  <a:srgbClr val="1F2A44"/>
+                </a:solidFill>
+                <a:latin typeface="맑은 고딕" pitchFamily="34" charset="0"/>
+                <a:ea typeface="맑은 고딕" pitchFamily="34" charset="-122"/>
+                <a:cs typeface="맑은 고딕" pitchFamily="34" charset="-120"/>
+              </a:rPr>
+              <a:t>신계약</a:t>
+            </a:r>
+            <a:endParaRPr lang="en-US" sz="1200" dirty="0"/>
+          </a:p>
+        </p:txBody>
+      </p:sp>
+      <p:sp>
+        <p:nvSpPr>
+          <p:cNvPr id="24" name="Text 22"/>
+          <p:cNvSpPr/>
+          <p:nvPr/>
+        </p:nvSpPr>
+        <p:spPr>
+          <a:xfrm>
+            <a:off x="795528" y="3521354"/>
+            <a:ext cx="2103120" cy="259232"/>
+          </a:xfrm>
+          <a:prstGeom prst="rect">
+            <a:avLst/>
+          </a:prstGeom>
+          <a:noFill/>
+          <a:ln/>
+        </p:spPr>
+        <p:txBody>
+          <a:bodyPr wrap="square" lIns="0" tIns="0" rIns="0" bIns="0" rtlCol="0" anchor="t"/>
+          <a:lstStyle/>
+          <a:p>
+            <a:pPr algn="l" indent="0" marL="0">
+              <a:buNone/>
+            </a:pPr>
+            <a:r>
+              <a:rPr lang="en-US" sz="900" dirty="0">
+                <a:solidFill>
+                  <a:srgbClr val="6B7280"/>
+                </a:solidFill>
+                <a:latin typeface="맑은 고딕" pitchFamily="34" charset="0"/>
+                <a:ea typeface="맑은 고딕" pitchFamily="34" charset="-122"/>
+                <a:cs typeface="맑은 고딕" pitchFamily="34" charset="-120"/>
+              </a:rPr>
+              <a:t>월납 환산</a:t>
+            </a:r>
+            <a:endParaRPr lang="en-US" sz="900" dirty="0"/>
+          </a:p>
+        </p:txBody>
+      </p:sp>
+      <p:sp>
+        <p:nvSpPr>
+          <p:cNvPr id="25" name="Shape 23"/>
+          <p:cNvSpPr/>
+          <p:nvPr/>
+        </p:nvSpPr>
+        <p:spPr>
+          <a:xfrm>
+            <a:off x="3035808" y="3200400"/>
+            <a:ext cx="2834640" cy="617220"/>
+          </a:xfrm>
+          <a:prstGeom prst="rect">
+            <a:avLst/>
+          </a:prstGeom>
+          <a:solidFill>
+            <a:srgbClr val="FFFFFF"/>
+          </a:solidFill>
+          <a:ln w="9525">
+            <a:solidFill>
+              <a:srgbClr val="D8DDE6"/>
+            </a:solidFill>
+            <a:prstDash val="solid"/>
+          </a:ln>
+        </p:spPr>
+      </p:sp>
+      <p:sp>
+        <p:nvSpPr>
+          <p:cNvPr id="26" name="Text 24"/>
+          <p:cNvSpPr/>
+          <p:nvPr/>
+        </p:nvSpPr>
+        <p:spPr>
+          <a:xfrm>
+            <a:off x="3108960" y="3200400"/>
+            <a:ext cx="2688336" cy="617220"/>
+          </a:xfrm>
+          <a:prstGeom prst="rect">
+            <a:avLst/>
+          </a:prstGeom>
+          <a:noFill/>
+          <a:ln/>
+        </p:spPr>
+        <p:txBody>
+          <a:bodyPr wrap="square" lIns="0" tIns="0" rIns="0" bIns="0" rtlCol="0" anchor="ctr"/>
+          <a:lstStyle/>
+          <a:p>
+            <a:pPr algn="ctr" indent="0" marL="0">
+              <a:buNone/>
+            </a:pPr>
+            <a:r>
+              <a:rPr lang="en-US" sz="1150" dirty="0">
+                <a:solidFill>
+                  <a:srgbClr val="1F2A44"/>
+                </a:solidFill>
+                <a:latin typeface="맑은 고딕" pitchFamily="34" charset="0"/>
+                <a:ea typeface="맑은 고딕" pitchFamily="34" charset="-122"/>
+                <a:cs typeface="맑은 고딕" pitchFamily="34" charset="-120"/>
+              </a:rPr>
+              <a:t>1,100건</a:t>
+            </a:r>
+            <a:endParaRPr lang="en-US" sz="1150" dirty="0"/>
+          </a:p>
+        </p:txBody>
+      </p:sp>
+      <p:sp>
+        <p:nvSpPr>
+          <p:cNvPr id="27" name="Shape 25"/>
+          <p:cNvSpPr/>
+          <p:nvPr/>
+        </p:nvSpPr>
+        <p:spPr>
+          <a:xfrm>
+            <a:off x="5870448" y="3200400"/>
+            <a:ext cx="2834640" cy="617220"/>
+          </a:xfrm>
+          <a:prstGeom prst="rect">
+            <a:avLst/>
+          </a:prstGeom>
+          <a:solidFill>
+            <a:srgbClr val="FFFFFF"/>
+          </a:solidFill>
+          <a:ln w="9525">
+            <a:solidFill>
+              <a:srgbClr val="D8DDE6"/>
+            </a:solidFill>
+            <a:prstDash val="solid"/>
+          </a:ln>
+        </p:spPr>
+      </p:sp>
+      <p:sp>
+        <p:nvSpPr>
+          <p:cNvPr id="28" name="Text 26"/>
+          <p:cNvSpPr/>
+          <p:nvPr/>
+        </p:nvSpPr>
+        <p:spPr>
+          <a:xfrm>
+            <a:off x="5943600" y="3200400"/>
+            <a:ext cx="2688336" cy="617220"/>
+          </a:xfrm>
+          <a:prstGeom prst="rect">
+            <a:avLst/>
+          </a:prstGeom>
+          <a:noFill/>
+          <a:ln/>
+        </p:spPr>
+        <p:txBody>
+          <a:bodyPr wrap="square" lIns="0" tIns="0" rIns="0" bIns="0" rtlCol="0" anchor="ctr"/>
+          <a:lstStyle/>
+          <a:p>
+            <a:pPr algn="ctr" indent="0" marL="0">
+              <a:buNone/>
+            </a:pPr>
+            <a:r>
+              <a:rPr lang="en-US" sz="1150" dirty="0">
+                <a:solidFill>
+                  <a:srgbClr val="1F2A44"/>
+                </a:solidFill>
+                <a:latin typeface="맑은 고딕" pitchFamily="34" charset="0"/>
+                <a:ea typeface="맑은 고딕" pitchFamily="34" charset="-122"/>
+                <a:cs typeface="맑은 고딕" pitchFamily="34" charset="-120"/>
+              </a:rPr>
+              <a:t>1,240건</a:t>
+            </a:r>
+            <a:endParaRPr lang="en-US" sz="1150" dirty="0"/>
+          </a:p>
+        </p:txBody>
+      </p:sp>
+      <p:sp>
+        <p:nvSpPr>
+          <p:cNvPr id="29" name="Shape 27"/>
+          <p:cNvSpPr/>
+          <p:nvPr/>
+        </p:nvSpPr>
+        <p:spPr>
+          <a:xfrm>
+            <a:off x="8705088" y="3200400"/>
+            <a:ext cx="2834640" cy="617220"/>
+          </a:xfrm>
+          <a:prstGeom prst="rect">
+            <a:avLst/>
+          </a:prstGeom>
+          <a:solidFill>
+            <a:srgbClr val="FFFFFF"/>
+          </a:solidFill>
+          <a:ln w="9525">
+            <a:solidFill>
+              <a:srgbClr val="D8DDE6"/>
+            </a:solidFill>
+            <a:prstDash val="solid"/>
+          </a:ln>
+        </p:spPr>
+      </p:sp>
+      <p:sp>
+        <p:nvSpPr>
+          <p:cNvPr id="30" name="Text 28"/>
+          <p:cNvSpPr/>
+          <p:nvPr/>
+        </p:nvSpPr>
+        <p:spPr>
+          <a:xfrm>
+            <a:off x="8778240" y="3200400"/>
+            <a:ext cx="2688336" cy="617220"/>
+          </a:xfrm>
+          <a:prstGeom prst="rect">
+            <a:avLst/>
+          </a:prstGeom>
+          <a:noFill/>
+          <a:ln/>
+        </p:spPr>
+        <p:txBody>
+          <a:bodyPr wrap="square" lIns="0" tIns="0" rIns="0" bIns="0" rtlCol="0" anchor="ctr"/>
+          <a:lstStyle/>
+          <a:p>
+            <a:pPr algn="ctr" indent="0" marL="0">
+              <a:buNone/>
+            </a:pPr>
+            <a:r>
+              <a:rPr lang="en-US" sz="1150" b="1" dirty="0">
+                <a:solidFill>
+                  <a:srgbClr val="0E8A6A"/>
+                </a:solidFill>
+                <a:latin typeface="맑은 고딕" pitchFamily="34" charset="0"/>
+                <a:ea typeface="맑은 고딕" pitchFamily="34" charset="-122"/>
+                <a:cs typeface="맑은 고딕" pitchFamily="34" charset="-120"/>
+              </a:rPr>
+              <a:t>113%</a:t>
+            </a:r>
+            <a:endParaRPr lang="en-US" sz="1150" dirty="0"/>
+          </a:p>
+        </p:txBody>
+      </p:sp>
+      <p:sp>
+        <p:nvSpPr>
+          <p:cNvPr id="31" name="Shape 29"/>
+          <p:cNvSpPr/>
+          <p:nvPr/>
+        </p:nvSpPr>
+        <p:spPr>
+          <a:xfrm>
+            <a:off x="658368" y="3817620"/>
+            <a:ext cx="2377440" cy="617220"/>
+          </a:xfrm>
+          <a:prstGeom prst="rect">
+            <a:avLst/>
+          </a:prstGeom>
+          <a:solidFill>
+            <a:srgbClr val="ECEFF3"/>
+          </a:solidFill>
+          <a:ln w="9525">
+            <a:solidFill>
+              <a:srgbClr val="D8DDE6"/>
+            </a:solidFill>
+            <a:prstDash val="solid"/>
+          </a:ln>
+        </p:spPr>
+      </p:sp>
+      <p:sp>
+        <p:nvSpPr>
+          <p:cNvPr id="32" name="Text 30"/>
+          <p:cNvSpPr/>
+          <p:nvPr/>
+        </p:nvSpPr>
+        <p:spPr>
+          <a:xfrm>
+            <a:off x="795528" y="3817620"/>
+            <a:ext cx="2103120" cy="617220"/>
+          </a:xfrm>
+          <a:prstGeom prst="rect">
+            <a:avLst/>
+          </a:prstGeom>
+          <a:noFill/>
+          <a:ln/>
+        </p:spPr>
+        <p:txBody>
+          <a:bodyPr wrap="square" lIns="0" tIns="0" rIns="0" bIns="0" rtlCol="0" anchor="ctr"/>
+          <a:lstStyle/>
+          <a:p>
+            <a:pPr algn="l" indent="0" marL="0">
+              <a:buNone/>
+            </a:pPr>
+            <a:r>
+              <a:rPr lang="en-US" sz="1200" b="1" dirty="0">
+                <a:solidFill>
+                  <a:srgbClr val="1F2A44"/>
+                </a:solidFill>
+                <a:latin typeface="맑은 고딕" pitchFamily="34" charset="0"/>
+                <a:ea typeface="맑은 고딕" pitchFamily="34" charset="-122"/>
+                <a:cs typeface="맑은 고딕" pitchFamily="34" charset="-120"/>
+              </a:rPr>
+              <a:t>보험료 수익</a:t>
+            </a:r>
+            <a:endParaRPr lang="en-US" sz="1200" dirty="0"/>
+          </a:p>
+        </p:txBody>
+      </p:sp>
+      <p:sp>
+        <p:nvSpPr>
+          <p:cNvPr id="33" name="Shape 31"/>
+          <p:cNvSpPr/>
+          <p:nvPr/>
+        </p:nvSpPr>
+        <p:spPr>
+          <a:xfrm>
+            <a:off x="3035808" y="3817620"/>
+            <a:ext cx="2834640" cy="617220"/>
+          </a:xfrm>
+          <a:prstGeom prst="rect">
+            <a:avLst/>
+          </a:prstGeom>
+          <a:solidFill>
+            <a:srgbClr val="FFFFFF"/>
+          </a:solidFill>
+          <a:ln w="9525">
+            <a:solidFill>
+              <a:srgbClr val="D8DDE6"/>
+            </a:solidFill>
+            <a:prstDash val="solid"/>
+          </a:ln>
+        </p:spPr>
+      </p:sp>
+      <p:sp>
+        <p:nvSpPr>
+          <p:cNvPr id="34" name="Text 32"/>
+          <p:cNvSpPr/>
+          <p:nvPr/>
+        </p:nvSpPr>
+        <p:spPr>
+          <a:xfrm>
+            <a:off x="3108960" y="3817620"/>
+            <a:ext cx="2688336" cy="617220"/>
+          </a:xfrm>
+          <a:prstGeom prst="rect">
+            <a:avLst/>
+          </a:prstGeom>
+          <a:noFill/>
+          <a:ln/>
+        </p:spPr>
+        <p:txBody>
+          <a:bodyPr wrap="square" lIns="0" tIns="0" rIns="0" bIns="0" rtlCol="0" anchor="ctr"/>
+          <a:lstStyle/>
+          <a:p>
+            <a:pPr algn="ctr" indent="0" marL="0">
+              <a:buNone/>
+            </a:pPr>
+            <a:r>
+              <a:rPr lang="en-US" sz="1150" dirty="0">
+                <a:solidFill>
+                  <a:srgbClr val="1F2A44"/>
+                </a:solidFill>
+                <a:latin typeface="맑은 고딕" pitchFamily="34" charset="0"/>
+                <a:ea typeface="맑은 고딕" pitchFamily="34" charset="-122"/>
+                <a:cs typeface="맑은 고딕" pitchFamily="34" charset="-120"/>
+              </a:rPr>
+              <a:t>84억원</a:t>
+            </a:r>
+            <a:endParaRPr lang="en-US" sz="1150" dirty="0"/>
+          </a:p>
+        </p:txBody>
+      </p:sp>
+      <p:sp>
+        <p:nvSpPr>
+          <p:cNvPr id="35" name="Shape 33"/>
+          <p:cNvSpPr/>
+          <p:nvPr/>
+        </p:nvSpPr>
+        <p:spPr>
+          <a:xfrm>
+            <a:off x="5870448" y="3817620"/>
+            <a:ext cx="2834640" cy="617220"/>
+          </a:xfrm>
+          <a:prstGeom prst="rect">
+            <a:avLst/>
+          </a:prstGeom>
+          <a:solidFill>
+            <a:srgbClr val="FFFFFF"/>
+          </a:solidFill>
+          <a:ln w="9525">
+            <a:solidFill>
+              <a:srgbClr val="D8DDE6"/>
+            </a:solidFill>
+            <a:prstDash val="solid"/>
+          </a:ln>
+        </p:spPr>
+      </p:sp>
+      <p:sp>
+        <p:nvSpPr>
+          <p:cNvPr id="36" name="Text 34"/>
+          <p:cNvSpPr/>
+          <p:nvPr/>
+        </p:nvSpPr>
+        <p:spPr>
+          <a:xfrm>
+            <a:off x="5943600" y="3817620"/>
+            <a:ext cx="2688336" cy="617220"/>
+          </a:xfrm>
+          <a:prstGeom prst="rect">
+            <a:avLst/>
+          </a:prstGeom>
+          <a:noFill/>
+          <a:ln/>
+        </p:spPr>
+        <p:txBody>
+          <a:bodyPr wrap="square" lIns="0" tIns="0" rIns="0" bIns="0" rtlCol="0" anchor="ctr"/>
+          <a:lstStyle/>
+          <a:p>
+            <a:pPr algn="ctr" indent="0" marL="0">
+              <a:buNone/>
+            </a:pPr>
+            <a:r>
+              <a:rPr lang="en-US" sz="1150" dirty="0">
+                <a:solidFill>
+                  <a:srgbClr val="1F2A44"/>
+                </a:solidFill>
+                <a:latin typeface="맑은 고딕" pitchFamily="34" charset="0"/>
+                <a:ea typeface="맑은 고딕" pitchFamily="34" charset="-122"/>
+                <a:cs typeface="맑은 고딕" pitchFamily="34" charset="-120"/>
+              </a:rPr>
+              <a:t>91억원</a:t>
+            </a:r>
+            <a:endParaRPr lang="en-US" sz="1150" dirty="0"/>
+          </a:p>
+        </p:txBody>
+      </p:sp>
+      <p:sp>
+        <p:nvSpPr>
+          <p:cNvPr id="37" name="Shape 35"/>
+          <p:cNvSpPr/>
+          <p:nvPr/>
+        </p:nvSpPr>
+        <p:spPr>
+          <a:xfrm>
+            <a:off x="8705088" y="3817620"/>
+            <a:ext cx="2834640" cy="617220"/>
+          </a:xfrm>
+          <a:prstGeom prst="rect">
+            <a:avLst/>
+          </a:prstGeom>
+          <a:solidFill>
+            <a:srgbClr val="FFFFFF"/>
+          </a:solidFill>
+          <a:ln w="9525">
+            <a:solidFill>
+              <a:srgbClr val="D8DDE6"/>
+            </a:solidFill>
+            <a:prstDash val="solid"/>
+          </a:ln>
+        </p:spPr>
+      </p:sp>
+      <p:sp>
+        <p:nvSpPr>
+          <p:cNvPr id="38" name="Text 36"/>
+          <p:cNvSpPr/>
+          <p:nvPr/>
+        </p:nvSpPr>
+        <p:spPr>
+          <a:xfrm>
+            <a:off x="8778240" y="3817620"/>
+            <a:ext cx="2688336" cy="617220"/>
+          </a:xfrm>
+          <a:prstGeom prst="rect">
+            <a:avLst/>
+          </a:prstGeom>
+          <a:noFill/>
+          <a:ln/>
+        </p:spPr>
+        <p:txBody>
+          <a:bodyPr wrap="square" lIns="0" tIns="0" rIns="0" bIns="0" rtlCol="0" anchor="ctr"/>
+          <a:lstStyle/>
+          <a:p>
+            <a:pPr algn="ctr" indent="0" marL="0">
+              <a:buNone/>
+            </a:pPr>
+            <a:r>
+              <a:rPr lang="en-US" sz="1150" b="1" dirty="0">
+                <a:solidFill>
+                  <a:srgbClr val="0E8A6A"/>
+                </a:solidFill>
+                <a:latin typeface="맑은 고딕" pitchFamily="34" charset="0"/>
+                <a:ea typeface="맑은 고딕" pitchFamily="34" charset="-122"/>
+                <a:cs typeface="맑은 고딕" pitchFamily="34" charset="-120"/>
+              </a:rPr>
+              <a:t>108%</a:t>
+            </a:r>
+            <a:endParaRPr lang="en-US" sz="1150" dirty="0"/>
+          </a:p>
+        </p:txBody>
+      </p:sp>
+      <p:sp>
+        <p:nvSpPr>
+          <p:cNvPr id="39" name="Shape 37"/>
+          <p:cNvSpPr/>
+          <p:nvPr/>
+        </p:nvSpPr>
+        <p:spPr>
+          <a:xfrm>
+            <a:off x="658368" y="4434840"/>
+            <a:ext cx="2377440" cy="617220"/>
+          </a:xfrm>
+          <a:prstGeom prst="rect">
+            <a:avLst/>
+          </a:prstGeom>
+          <a:solidFill>
+            <a:srgbClr val="ECEFF3"/>
+          </a:solidFill>
+          <a:ln w="9525">
+            <a:solidFill>
+              <a:srgbClr val="D8DDE6"/>
+            </a:solidFill>
+            <a:prstDash val="solid"/>
+          </a:ln>
+        </p:spPr>
+      </p:sp>
+      <p:sp>
+        <p:nvSpPr>
+          <p:cNvPr id="40" name="Text 38"/>
+          <p:cNvSpPr/>
+          <p:nvPr/>
+        </p:nvSpPr>
+        <p:spPr>
+          <a:xfrm>
+            <a:off x="795528" y="4434840"/>
+            <a:ext cx="2103120" cy="617220"/>
+          </a:xfrm>
+          <a:prstGeom prst="rect">
+            <a:avLst/>
+          </a:prstGeom>
+          <a:noFill/>
+          <a:ln/>
+        </p:spPr>
+        <p:txBody>
+          <a:bodyPr wrap="square" lIns="0" tIns="0" rIns="0" bIns="0" rtlCol="0" anchor="ctr"/>
+          <a:lstStyle/>
+          <a:p>
+            <a:pPr algn="l" indent="0" marL="0">
+              <a:buNone/>
+            </a:pPr>
+            <a:r>
+              <a:rPr lang="en-US" sz="1200" b="1" dirty="0">
+                <a:solidFill>
+                  <a:srgbClr val="1F2A44"/>
+                </a:solidFill>
+                <a:latin typeface="맑은 고딕" pitchFamily="34" charset="0"/>
+                <a:ea typeface="맑은 고딕" pitchFamily="34" charset="-122"/>
+                <a:cs typeface="맑은 고딕" pitchFamily="34" charset="-120"/>
+              </a:rPr>
+              <a:t>13회차 유지율</a:t>
+            </a:r>
+            <a:endParaRPr lang="en-US" sz="1200" dirty="0"/>
+          </a:p>
+        </p:txBody>
+      </p:sp>
+      <p:sp>
+        <p:nvSpPr>
+          <p:cNvPr id="41" name="Shape 39"/>
+          <p:cNvSpPr/>
+          <p:nvPr/>
+        </p:nvSpPr>
+        <p:spPr>
+          <a:xfrm>
+            <a:off x="3035808" y="4434840"/>
+            <a:ext cx="2834640" cy="617220"/>
+          </a:xfrm>
+          <a:prstGeom prst="rect">
+            <a:avLst/>
+          </a:prstGeom>
+          <a:solidFill>
+            <a:srgbClr val="FFFFFF"/>
+          </a:solidFill>
+          <a:ln w="9525">
+            <a:solidFill>
+              <a:srgbClr val="D8DDE6"/>
+            </a:solidFill>
+            <a:prstDash val="solid"/>
+          </a:ln>
+        </p:spPr>
+      </p:sp>
+      <p:sp>
+        <p:nvSpPr>
+          <p:cNvPr id="42" name="Text 40"/>
+          <p:cNvSpPr/>
+          <p:nvPr/>
+        </p:nvSpPr>
+        <p:spPr>
+          <a:xfrm>
+            <a:off x="3108960" y="4434840"/>
+            <a:ext cx="2688336" cy="617220"/>
+          </a:xfrm>
+          <a:prstGeom prst="rect">
+            <a:avLst/>
+          </a:prstGeom>
+          <a:noFill/>
+          <a:ln/>
+        </p:spPr>
+        <p:txBody>
+          <a:bodyPr wrap="square" lIns="0" tIns="0" rIns="0" bIns="0" rtlCol="0" anchor="ctr"/>
+          <a:lstStyle/>
+          <a:p>
+            <a:pPr algn="ctr" indent="0" marL="0">
+              <a:buNone/>
+            </a:pPr>
+            <a:r>
+              <a:rPr lang="en-US" sz="1150" dirty="0">
+                <a:solidFill>
+                  <a:srgbClr val="1F2A44"/>
+                </a:solidFill>
+                <a:latin typeface="맑은 고딕" pitchFamily="34" charset="0"/>
+                <a:ea typeface="맑은 고딕" pitchFamily="34" charset="-122"/>
+                <a:cs typeface="맑은 고딕" pitchFamily="34" charset="-120"/>
+              </a:rPr>
+              <a:t>85%</a:t>
+            </a:r>
+            <a:endParaRPr lang="en-US" sz="1150" dirty="0"/>
+          </a:p>
+        </p:txBody>
+      </p:sp>
+      <p:sp>
+        <p:nvSpPr>
+          <p:cNvPr id="43" name="Shape 41"/>
+          <p:cNvSpPr/>
+          <p:nvPr/>
+        </p:nvSpPr>
+        <p:spPr>
+          <a:xfrm>
+            <a:off x="5870448" y="4434840"/>
+            <a:ext cx="2834640" cy="617220"/>
+          </a:xfrm>
+          <a:prstGeom prst="rect">
+            <a:avLst/>
+          </a:prstGeom>
+          <a:solidFill>
+            <a:srgbClr val="FFFFFF"/>
+          </a:solidFill>
+          <a:ln w="9525">
+            <a:solidFill>
+              <a:srgbClr val="D8DDE6"/>
+            </a:solidFill>
+            <a:prstDash val="solid"/>
+          </a:ln>
+        </p:spPr>
+      </p:sp>
+      <p:sp>
+        <p:nvSpPr>
+          <p:cNvPr id="44" name="Text 42"/>
+          <p:cNvSpPr/>
+          <p:nvPr/>
+        </p:nvSpPr>
+        <p:spPr>
+          <a:xfrm>
+            <a:off x="5943600" y="4434840"/>
+            <a:ext cx="2688336" cy="617220"/>
+          </a:xfrm>
+          <a:prstGeom prst="rect">
+            <a:avLst/>
+          </a:prstGeom>
+          <a:noFill/>
+          <a:ln/>
+        </p:spPr>
+        <p:txBody>
+          <a:bodyPr wrap="square" lIns="0" tIns="0" rIns="0" bIns="0" rtlCol="0" anchor="ctr"/>
+          <a:lstStyle/>
+          <a:p>
+            <a:pPr algn="ctr" indent="0" marL="0">
+              <a:buNone/>
+            </a:pPr>
+            <a:r>
+              <a:rPr lang="en-US" sz="1150" dirty="0">
+                <a:solidFill>
+                  <a:srgbClr val="1F2A44"/>
+                </a:solidFill>
+                <a:latin typeface="맑은 고딕" pitchFamily="34" charset="0"/>
+                <a:ea typeface="맑은 고딕" pitchFamily="34" charset="-122"/>
+                <a:cs typeface="맑은 고딕" pitchFamily="34" charset="-120"/>
+              </a:rPr>
+              <a:t>87%</a:t>
+            </a:r>
+            <a:endParaRPr lang="en-US" sz="1150" dirty="0"/>
+          </a:p>
+        </p:txBody>
+      </p:sp>
+      <p:sp>
+        <p:nvSpPr>
+          <p:cNvPr id="45" name="Shape 43"/>
+          <p:cNvSpPr/>
+          <p:nvPr/>
+        </p:nvSpPr>
+        <p:spPr>
+          <a:xfrm>
+            <a:off x="8705088" y="4434840"/>
+            <a:ext cx="2834640" cy="617220"/>
+          </a:xfrm>
+          <a:prstGeom prst="rect">
+            <a:avLst/>
+          </a:prstGeom>
+          <a:solidFill>
+            <a:srgbClr val="FFFFFF"/>
+          </a:solidFill>
+          <a:ln w="9525">
+            <a:solidFill>
+              <a:srgbClr val="D8DDE6"/>
+            </a:solidFill>
+            <a:prstDash val="solid"/>
+          </a:ln>
+        </p:spPr>
+      </p:sp>
+      <p:sp>
+        <p:nvSpPr>
+          <p:cNvPr id="46" name="Text 44"/>
+          <p:cNvSpPr/>
+          <p:nvPr/>
+        </p:nvSpPr>
+        <p:spPr>
+          <a:xfrm>
+            <a:off x="8778240" y="4434840"/>
+            <a:ext cx="2688336" cy="617220"/>
+          </a:xfrm>
+          <a:prstGeom prst="rect">
+            <a:avLst/>
+          </a:prstGeom>
+          <a:noFill/>
+          <a:ln/>
+        </p:spPr>
+        <p:txBody>
+          <a:bodyPr wrap="square" lIns="0" tIns="0" rIns="0" bIns="0" rtlCol="0" anchor="ctr"/>
+          <a:lstStyle/>
+          <a:p>
+            <a:pPr algn="ctr" indent="0" marL="0">
+              <a:buNone/>
+            </a:pPr>
+            <a:r>
+              <a:rPr lang="en-US" sz="1150" b="1" dirty="0">
+                <a:solidFill>
+                  <a:srgbClr val="0E8A6A"/>
+                </a:solidFill>
+                <a:latin typeface="맑은 고딕" pitchFamily="34" charset="0"/>
+                <a:ea typeface="맑은 고딕" pitchFamily="34" charset="-122"/>
+                <a:cs typeface="맑은 고딕" pitchFamily="34" charset="-120"/>
+              </a:rPr>
+              <a:t>102%</a:t>
+            </a:r>
+            <a:endParaRPr lang="en-US" sz="1150" dirty="0"/>
+          </a:p>
+        </p:txBody>
+      </p:sp>
+      <p:sp>
+        <p:nvSpPr>
+          <p:cNvPr id="47" name="Shape 45"/>
+          <p:cNvSpPr/>
+          <p:nvPr/>
+        </p:nvSpPr>
+        <p:spPr>
+          <a:xfrm>
+            <a:off x="658368" y="5052060"/>
+            <a:ext cx="2377440" cy="617220"/>
+          </a:xfrm>
+          <a:prstGeom prst="rect">
+            <a:avLst/>
+          </a:prstGeom>
+          <a:solidFill>
+            <a:srgbClr val="ECEFF3"/>
+          </a:solidFill>
+          <a:ln w="9525">
+            <a:solidFill>
+              <a:srgbClr val="D8DDE6"/>
+            </a:solidFill>
+            <a:prstDash val="solid"/>
+          </a:ln>
+        </p:spPr>
+      </p:sp>
+      <p:sp>
+        <p:nvSpPr>
+          <p:cNvPr id="48" name="Text 46"/>
+          <p:cNvSpPr/>
+          <p:nvPr/>
+        </p:nvSpPr>
+        <p:spPr>
+          <a:xfrm>
+            <a:off x="795528" y="5052060"/>
+            <a:ext cx="2103120" cy="617220"/>
+          </a:xfrm>
+          <a:prstGeom prst="rect">
+            <a:avLst/>
+          </a:prstGeom>
+          <a:noFill/>
+          <a:ln/>
+        </p:spPr>
+        <p:txBody>
+          <a:bodyPr wrap="square" lIns="0" tIns="0" rIns="0" bIns="0" rtlCol="0" anchor="ctr"/>
+          <a:lstStyle/>
+          <a:p>
+            <a:pPr algn="l" indent="0" marL="0">
+              <a:buNone/>
+            </a:pPr>
+            <a:r>
+              <a:rPr lang="en-US" sz="1200" b="1" dirty="0">
+                <a:solidFill>
+                  <a:srgbClr val="1F2A44"/>
+                </a:solidFill>
+                <a:latin typeface="맑은 고딕" pitchFamily="34" charset="0"/>
+                <a:ea typeface="맑은 고딕" pitchFamily="34" charset="-122"/>
+                <a:cs typeface="맑은 고딕" pitchFamily="34" charset="-120"/>
+              </a:rPr>
+              <a:t>손해율</a:t>
+            </a:r>
+            <a:endParaRPr lang="en-US" sz="1200" dirty="0"/>
+          </a:p>
+        </p:txBody>
+      </p:sp>
+      <p:sp>
+        <p:nvSpPr>
+          <p:cNvPr id="49" name="Shape 47"/>
+          <p:cNvSpPr/>
+          <p:nvPr/>
+        </p:nvSpPr>
+        <p:spPr>
+          <a:xfrm>
+            <a:off x="3035808" y="5052060"/>
+            <a:ext cx="2834640" cy="617220"/>
+          </a:xfrm>
+          <a:prstGeom prst="rect">
+            <a:avLst/>
+          </a:prstGeom>
+          <a:solidFill>
+            <a:srgbClr val="FFFFFF"/>
+          </a:solidFill>
+          <a:ln w="9525">
+            <a:solidFill>
+              <a:srgbClr val="D8DDE6"/>
+            </a:solidFill>
+            <a:prstDash val="solid"/>
+          </a:ln>
+        </p:spPr>
+      </p:sp>
+      <p:sp>
+        <p:nvSpPr>
+          <p:cNvPr id="50" name="Text 48"/>
+          <p:cNvSpPr/>
+          <p:nvPr/>
+        </p:nvSpPr>
+        <p:spPr>
+          <a:xfrm>
+            <a:off x="3108960" y="5052060"/>
+            <a:ext cx="2688336" cy="617220"/>
+          </a:xfrm>
+          <a:prstGeom prst="rect">
+            <a:avLst/>
+          </a:prstGeom>
+          <a:noFill/>
+          <a:ln/>
+        </p:spPr>
+        <p:txBody>
+          <a:bodyPr wrap="square" lIns="0" tIns="0" rIns="0" bIns="0" rtlCol="0" anchor="ctr"/>
+          <a:lstStyle/>
+          <a:p>
+            <a:pPr algn="ctr" indent="0" marL="0">
+              <a:buNone/>
+            </a:pPr>
+            <a:r>
+              <a:rPr lang="en-US" sz="1150" dirty="0">
+                <a:solidFill>
+                  <a:srgbClr val="1F2A44"/>
+                </a:solidFill>
+                <a:latin typeface="맑은 고딕" pitchFamily="34" charset="0"/>
+                <a:ea typeface="맑은 고딕" pitchFamily="34" charset="-122"/>
+                <a:cs typeface="맑은 고딕" pitchFamily="34" charset="-120"/>
+              </a:rPr>
+              <a:t>82%</a:t>
+            </a:r>
+            <a:endParaRPr lang="en-US" sz="1150" dirty="0"/>
+          </a:p>
+        </p:txBody>
+      </p:sp>
+      <p:sp>
+        <p:nvSpPr>
+          <p:cNvPr id="51" name="Shape 49"/>
+          <p:cNvSpPr/>
+          <p:nvPr/>
+        </p:nvSpPr>
+        <p:spPr>
+          <a:xfrm>
+            <a:off x="5870448" y="5052060"/>
+            <a:ext cx="2834640" cy="617220"/>
+          </a:xfrm>
+          <a:prstGeom prst="rect">
+            <a:avLst/>
+          </a:prstGeom>
+          <a:solidFill>
+            <a:srgbClr val="FFFFFF"/>
+          </a:solidFill>
+          <a:ln w="9525">
+            <a:solidFill>
+              <a:srgbClr val="D8DDE6"/>
+            </a:solidFill>
+            <a:prstDash val="solid"/>
+          </a:ln>
+        </p:spPr>
+      </p:sp>
+      <p:sp>
+        <p:nvSpPr>
+          <p:cNvPr id="52" name="Text 50"/>
+          <p:cNvSpPr/>
+          <p:nvPr/>
+        </p:nvSpPr>
+        <p:spPr>
+          <a:xfrm>
+            <a:off x="5943600" y="5052060"/>
+            <a:ext cx="2688336" cy="617220"/>
+          </a:xfrm>
+          <a:prstGeom prst="rect">
+            <a:avLst/>
+          </a:prstGeom>
+          <a:noFill/>
+          <a:ln/>
+        </p:spPr>
+        <p:txBody>
+          <a:bodyPr wrap="square" lIns="0" tIns="0" rIns="0" bIns="0" rtlCol="0" anchor="ctr"/>
+          <a:lstStyle/>
+          <a:p>
+            <a:pPr algn="ctr" indent="0" marL="0">
+              <a:buNone/>
+            </a:pPr>
+            <a:r>
+              <a:rPr lang="en-US" sz="1150" dirty="0">
+                <a:solidFill>
+                  <a:srgbClr val="1F2A44"/>
+                </a:solidFill>
+                <a:latin typeface="맑은 고딕" pitchFamily="34" charset="0"/>
+                <a:ea typeface="맑은 고딕" pitchFamily="34" charset="-122"/>
+                <a:cs typeface="맑은 고딕" pitchFamily="34" charset="-120"/>
+              </a:rPr>
+              <a:t>85%</a:t>
+            </a:r>
+            <a:endParaRPr lang="en-US" sz="1150" dirty="0"/>
+          </a:p>
+        </p:txBody>
+      </p:sp>
+      <p:sp>
+        <p:nvSpPr>
+          <p:cNvPr id="53" name="Shape 51"/>
+          <p:cNvSpPr/>
+          <p:nvPr/>
+        </p:nvSpPr>
+        <p:spPr>
+          <a:xfrm>
+            <a:off x="8705088" y="5052060"/>
+            <a:ext cx="2834640" cy="617220"/>
+          </a:xfrm>
+          <a:prstGeom prst="rect">
+            <a:avLst/>
+          </a:prstGeom>
+          <a:solidFill>
+            <a:srgbClr val="FFFFFF"/>
+          </a:solidFill>
+          <a:ln w="9525">
+            <a:solidFill>
+              <a:srgbClr val="D8DDE6"/>
+            </a:solidFill>
+            <a:prstDash val="solid"/>
+          </a:ln>
+        </p:spPr>
+      </p:sp>
+      <p:sp>
+        <p:nvSpPr>
+          <p:cNvPr id="54" name="Text 52"/>
+          <p:cNvSpPr/>
+          <p:nvPr/>
+        </p:nvSpPr>
+        <p:spPr>
+          <a:xfrm>
+            <a:off x="8778240" y="5052060"/>
+            <a:ext cx="2688336" cy="617220"/>
+          </a:xfrm>
+          <a:prstGeom prst="rect">
+            <a:avLst/>
+          </a:prstGeom>
+          <a:noFill/>
+          <a:ln/>
+        </p:spPr>
+        <p:txBody>
+          <a:bodyPr wrap="square" lIns="0" tIns="0" rIns="0" bIns="0" rtlCol="0" anchor="ctr"/>
+          <a:lstStyle/>
+          <a:p>
+            <a:pPr algn="ctr" indent="0" marL="0">
+              <a:buNone/>
+            </a:pPr>
+            <a:r>
+              <a:rPr lang="en-US" sz="1150" b="1" dirty="0">
+                <a:solidFill>
+                  <a:srgbClr val="C6392E"/>
+                </a:solidFill>
+                <a:latin typeface="맑은 고딕" pitchFamily="34" charset="0"/>
+                <a:ea typeface="맑은 고딕" pitchFamily="34" charset="-122"/>
+                <a:cs typeface="맑은 고딕" pitchFamily="34" charset="-120"/>
+              </a:rPr>
+              <a:t>미달</a:t>
+            </a:r>
+            <a:endParaRPr lang="en-US" sz="1150" dirty="0"/>
+          </a:p>
+        </p:txBody>
+      </p:sp>
+      <p:sp>
+        <p:nvSpPr>
+          <p:cNvPr id="55" name="Text 53"/>
+          <p:cNvSpPr/>
+          <p:nvPr/>
+        </p:nvSpPr>
+        <p:spPr>
+          <a:xfrm>
+            <a:off x="822960" y="6272784"/>
+            <a:ext cx="10515600" cy="182880"/>
+          </a:xfrm>
+          <a:prstGeom prst="rect">
+            <a:avLst/>
+          </a:prstGeom>
+          <a:noFill/>
+          <a:ln/>
+        </p:spPr>
+        <p:txBody>
+          <a:bodyPr wrap="square" lIns="0" tIns="0" rIns="0" bIns="0" rtlCol="0" anchor="ctr"/>
+          <a:lstStyle/>
+          <a:p>
+            <a:pPr algn="l" indent="0" marL="0">
+              <a:buNone/>
+            </a:pPr>
+            <a:r>
+              <a:rPr lang="en-US" sz="850" dirty="0">
+                <a:solidFill>
+                  <a:srgbClr val="8A93A4"/>
+                </a:solidFill>
+                <a:latin typeface="맑은 고딕" pitchFamily="34" charset="0"/>
+                <a:ea typeface="맑은 고딕" pitchFamily="34" charset="-122"/>
+                <a:cs typeface="맑은 고딕" pitchFamily="34" charset="-120"/>
+              </a:rPr>
+              <a:t>* 수치는 전건 가정(예시), 실제 월간 집계로 대체 필요</a:t>
+            </a:r>
+            <a:endParaRPr lang="en-US" sz="850" dirty="0"/>
+          </a:p>
+        </p:txBody>
+      </p:sp>
+    </p:spTree>
+  </p:cSld>
+  <p:clrMapOvr>
+    <a:masterClrMapping/>
+  </p:clrMapOvr>
+</p:sld>
+</file>
+
+<file path=ppt/slides/slide9.xml><?xml version="1.0" encoding="utf-8"?>
+<p:sld xmlns:a="http://schemas.openxmlformats.org/drawingml/2006/main" xmlns:r="http://schemas.openxmlformats.org/officeDocument/2006/relationships" xmlns:p="http://schemas.openxmlformats.org/presentationml/2006/main">
+  <p:cSld name="Slide 9">
+    <p:bg>
+      <p:bgPr>
+        <a:solidFill>
+          <a:srgbClr val="F2F4F7"/>
+        </a:solidFill>
+      </p:bgPr>
+    </p:bg>
+    <p:spTree>
+      <p:nvGrpSpPr>
+        <p:cNvPr id="1" name=""/>
+        <p:cNvGrpSpPr/>
+        <p:nvPr/>
+      </p:nvGrpSpPr>
+      <p:grpSpPr>
+        <a:xfrm>
+          <a:off x="0" y="0"/>
+          <a:ext cx="0" cy="0"/>
+          <a:chOff x="0" y="0"/>
+          <a:chExt cx="0" cy="0"/>
+        </a:xfrm>
+      </p:grpSpPr>
+      <p:sp>
+        <p:nvSpPr>
+          <p:cNvPr id="2" name="Text 0"/>
+          <p:cNvSpPr/>
+          <p:nvPr/>
+        </p:nvSpPr>
+        <p:spPr>
+          <a:xfrm>
+            <a:off x="365760" y="91440"/>
+            <a:ext cx="3657600" cy="201168"/>
+          </a:xfrm>
+          <a:prstGeom prst="rect">
+            <a:avLst/>
+          </a:prstGeom>
+          <a:noFill/>
+          <a:ln/>
+        </p:spPr>
+        <p:txBody>
+          <a:bodyPr wrap="square" lIns="0" tIns="0" rIns="0" bIns="0" rtlCol="0" anchor="ctr"/>
+          <a:lstStyle/>
+          <a:p>
+            <a:pPr algn="l" indent="0" marL="0">
+              <a:buNone/>
+            </a:pPr>
+            <a:r>
+              <a:rPr lang="en-US" sz="800" dirty="0">
+                <a:solidFill>
+                  <a:srgbClr val="8A93A4"/>
+                </a:solidFill>
+                <a:latin typeface="맑은 고딕" pitchFamily="34" charset="0"/>
+                <a:ea typeface="맑은 고딕" pitchFamily="34" charset="-122"/>
+                <a:cs typeface="맑은 고딕" pitchFamily="34" charset="-120"/>
+              </a:rPr>
+              <a:t>템플릿 쇼케이스</a:t>
+            </a:r>
+            <a:endParaRPr lang="en-US" sz="800" dirty="0"/>
+          </a:p>
+        </p:txBody>
+      </p:sp>
+      <p:sp>
+        <p:nvSpPr>
+          <p:cNvPr id="3" name="Text 1"/>
+          <p:cNvSpPr/>
+          <p:nvPr/>
+        </p:nvSpPr>
+        <p:spPr>
+          <a:xfrm>
+            <a:off x="365760" y="329184"/>
+            <a:ext cx="8778240" cy="512064"/>
+          </a:xfrm>
+          <a:prstGeom prst="rect">
+            <a:avLst/>
+          </a:prstGeom>
+          <a:noFill/>
+          <a:ln/>
+        </p:spPr>
+        <p:txBody>
+          <a:bodyPr wrap="square" lIns="0" tIns="0" rIns="0" bIns="0" rtlCol="0" anchor="ctr"/>
+          <a:lstStyle/>
+          <a:p>
+            <a:pPr algn="l" indent="0" marL="0">
+              <a:buNone/>
+            </a:pPr>
+            <a:r>
+              <a:rPr lang="en-US" sz="2700" b="1" dirty="0">
+                <a:solidFill>
+                  <a:srgbClr val="0F1E5A"/>
+                </a:solidFill>
+                <a:latin typeface="맑은 고딕" pitchFamily="34" charset="0"/>
+                <a:ea typeface="맑은 고딕" pitchFamily="34" charset="-122"/>
+                <a:cs typeface="맑은 고딕" pitchFamily="34" charset="-120"/>
+              </a:rPr>
+              <a:t>계열사 비교</a:t>
+            </a:r>
+            <a:endParaRPr lang="en-US" sz="2700" dirty="0"/>
+          </a:p>
+        </p:txBody>
+      </p:sp>
+      <p:sp>
+        <p:nvSpPr>
+          <p:cNvPr id="4" name="Shape 2"/>
+          <p:cNvSpPr/>
+          <p:nvPr/>
+        </p:nvSpPr>
+        <p:spPr>
+          <a:xfrm>
+            <a:off x="9418320" y="402336"/>
+            <a:ext cx="2432304" cy="402336"/>
+          </a:xfrm>
+          <a:prstGeom prst="roundRect">
+            <a:avLst>
+              <a:gd name="adj" fmla="val 50000"/>
+            </a:avLst>
+          </a:prstGeom>
+          <a:solidFill>
+            <a:srgbClr val="4FC8DF"/>
+          </a:solidFill>
+          <a:ln/>
+        </p:spPr>
+      </p:sp>
+      <p:sp>
+        <p:nvSpPr>
+          <p:cNvPr id="5" name="Text 3"/>
+          <p:cNvSpPr/>
+          <p:nvPr/>
+        </p:nvSpPr>
+        <p:spPr>
+          <a:xfrm>
+            <a:off x="9418320" y="402336"/>
+            <a:ext cx="2432304" cy="402336"/>
+          </a:xfrm>
+          <a:prstGeom prst="rect">
+            <a:avLst/>
+          </a:prstGeom>
+          <a:noFill/>
+          <a:ln/>
+        </p:spPr>
+        <p:txBody>
+          <a:bodyPr wrap="square" lIns="0" tIns="0" rIns="0" bIns="0" rtlCol="0" anchor="ctr"/>
+          <a:lstStyle/>
+          <a:p>
+            <a:pPr algn="ctr" indent="0" marL="0">
+              <a:buNone/>
+            </a:pPr>
+            <a:r>
+              <a:rPr lang="en-US" sz="1300" b="1" dirty="0">
+                <a:solidFill>
+                  <a:srgbClr val="0F1E5A"/>
+                </a:solidFill>
+                <a:latin typeface="맑은 고딕" pitchFamily="34" charset="0"/>
+                <a:ea typeface="맑은 고딕" pitchFamily="34" charset="-122"/>
+                <a:cs typeface="맑은 고딕" pitchFamily="34" charset="-120"/>
+              </a:rPr>
+              <a:t>비교표</a:t>
+            </a:r>
+            <a:endParaRPr lang="en-US" sz="1300" dirty="0"/>
+          </a:p>
+        </p:txBody>
+      </p:sp>
+      <p:sp>
+        <p:nvSpPr>
+          <p:cNvPr id="6" name="Shape 4"/>
+          <p:cNvSpPr/>
+          <p:nvPr/>
+        </p:nvSpPr>
+        <p:spPr>
+          <a:xfrm>
+            <a:off x="329184" y="1005840"/>
+            <a:ext cx="11530584" cy="5541264"/>
+          </a:xfrm>
+          <a:prstGeom prst="roundRect">
+            <a:avLst>
+              <a:gd name="adj" fmla="val 990"/>
+            </a:avLst>
+          </a:prstGeom>
+          <a:solidFill>
+            <a:srgbClr val="FFFFFF"/>
+          </a:solidFill>
+          <a:ln w="12700">
+            <a:solidFill>
+              <a:srgbClr val="D8DDE6"/>
+            </a:solidFill>
+            <a:prstDash val="solid"/>
+          </a:ln>
+        </p:spPr>
+      </p:sp>
+      <p:sp>
+        <p:nvSpPr>
+          <p:cNvPr id="7" name="Text 5"/>
+          <p:cNvSpPr/>
+          <p:nvPr/>
+        </p:nvSpPr>
+        <p:spPr>
+          <a:xfrm>
+            <a:off x="11475720" y="6583680"/>
+            <a:ext cx="457200" cy="201168"/>
+          </a:xfrm>
+          <a:prstGeom prst="rect">
+            <a:avLst/>
+          </a:prstGeom>
+          <a:noFill/>
+          <a:ln/>
+        </p:spPr>
+        <p:txBody>
+          <a:bodyPr wrap="square" lIns="0" tIns="0" rIns="0" bIns="0" rtlCol="0" anchor="ctr"/>
+          <a:lstStyle/>
+          <a:p>
+            <a:pPr algn="r" indent="0" marL="0">
+              <a:buNone/>
+            </a:pPr>
+            <a:r>
+              <a:rPr lang="en-US" sz="900" dirty="0">
+                <a:solidFill>
+                  <a:srgbClr val="8A93A4"/>
+                </a:solidFill>
+                <a:latin typeface="맑은 고딕" pitchFamily="34" charset="0"/>
+                <a:ea typeface="맑은 고딕" pitchFamily="34" charset="-122"/>
+                <a:cs typeface="맑은 고딕" pitchFamily="34" charset="-120"/>
+              </a:rPr>
+              <a:t>9</a:t>
+            </a:r>
+            <a:endParaRPr lang="en-US" sz="900" dirty="0"/>
+          </a:p>
+        </p:txBody>
+      </p:sp>
+      <p:sp>
+        <p:nvSpPr>
+          <p:cNvPr id="8" name="Shape 6"/>
+          <p:cNvSpPr/>
+          <p:nvPr/>
+        </p:nvSpPr>
+        <p:spPr>
+          <a:xfrm>
+            <a:off x="658368" y="1243584"/>
+            <a:ext cx="64008" cy="457200"/>
+          </a:xfrm>
+          <a:prstGeom prst="rect">
+            <a:avLst/>
+          </a:prstGeom>
+          <a:solidFill>
+            <a:srgbClr val="0F1E5A"/>
+          </a:solidFill>
+          <a:ln/>
+        </p:spPr>
+      </p:sp>
+      <p:sp>
+        <p:nvSpPr>
+          <p:cNvPr id="9" name="Text 7"/>
+          <p:cNvSpPr/>
+          <p:nvPr/>
+        </p:nvSpPr>
+        <p:spPr>
+          <a:xfrm>
+            <a:off x="859536" y="1188720"/>
+            <a:ext cx="10607040" cy="548640"/>
+          </a:xfrm>
+          <a:prstGeom prst="rect">
+            <a:avLst/>
+          </a:prstGeom>
+          <a:noFill/>
+          <a:ln/>
+        </p:spPr>
+        <p:txBody>
+          <a:bodyPr wrap="square" lIns="0" tIns="0" rIns="0" bIns="0" rtlCol="0" anchor="ctr"/>
+          <a:lstStyle/>
+          <a:p>
+            <a:pPr algn="l" indent="0" marL="0">
+              <a:buNone/>
+            </a:pPr>
+            <a:r>
+              <a:rPr lang="en-US" sz="1900" b="1" dirty="0">
+                <a:solidFill>
+                  <a:srgbClr val="1F2A44"/>
+                </a:solidFill>
+                <a:latin typeface="맑은 고딕" pitchFamily="34" charset="0"/>
+                <a:ea typeface="맑은 고딕" pitchFamily="34" charset="-122"/>
+                <a:cs typeface="맑은 고딕" pitchFamily="34" charset="-120"/>
+              </a:rPr>
+              <a:t>성장률과 유지율에서 당사가 </a:t>
+            </a:r>
+            <a:pPr algn="l" indent="0" marL="0">
+              <a:buNone/>
+            </a:pPr>
+            <a:r>
+              <a:rPr lang="en-US" sz="1900" b="1" dirty="0">
+                <a:solidFill>
+                  <a:srgbClr val="1F2A44"/>
+                </a:solidFill>
+                <a:highlight>
+                  <a:srgbClr val="FFF04D"/>
+                </a:highlight>
+                <a:latin typeface="맑은 고딕" pitchFamily="34" charset="0"/>
+                <a:ea typeface="맑은 고딕" pitchFamily="34" charset="-122"/>
+                <a:cs typeface="맑은 고딕" pitchFamily="34" charset="-120"/>
+              </a:rPr>
+              <a:t>상위권</a:t>
+            </a:r>
+            <a:pPr algn="l" indent="0" marL="0">
+              <a:buNone/>
+            </a:pPr>
+            <a:r>
+              <a:rPr lang="en-US" sz="1900" b="1" dirty="0">
+                <a:solidFill>
+                  <a:srgbClr val="1F2A44"/>
+                </a:solidFill>
+                <a:latin typeface="맑은 고딕" pitchFamily="34" charset="0"/>
+                <a:ea typeface="맑은 고딕" pitchFamily="34" charset="-122"/>
+                <a:cs typeface="맑은 고딕" pitchFamily="34" charset="-120"/>
+              </a:rPr>
+              <a:t>을 유지함</a:t>
+            </a:r>
+            <a:endParaRPr lang="en-US" sz="1900" dirty="0"/>
+          </a:p>
+        </p:txBody>
+      </p:sp>
+      <p:sp>
+        <p:nvSpPr>
+          <p:cNvPr id="10" name="Text 8"/>
+          <p:cNvSpPr/>
+          <p:nvPr/>
+        </p:nvSpPr>
+        <p:spPr>
+          <a:xfrm>
+            <a:off x="877824" y="1792224"/>
+            <a:ext cx="10515600" cy="274320"/>
+          </a:xfrm>
+          <a:prstGeom prst="rect">
+            <a:avLst/>
+          </a:prstGeom>
+          <a:noFill/>
+          <a:ln/>
+        </p:spPr>
+        <p:txBody>
+          <a:bodyPr wrap="square" lIns="0" tIns="0" rIns="0" bIns="0" rtlCol="0" anchor="ctr"/>
+          <a:lstStyle/>
+          <a:p>
+            <a:pPr algn="l" indent="0" marL="0">
+              <a:buNone/>
+            </a:pPr>
+            <a:r>
+              <a:rPr lang="en-US" sz="1300" dirty="0">
+                <a:solidFill>
+                  <a:srgbClr val="5A6472"/>
+                </a:solidFill>
+                <a:latin typeface="맑은 고딕" pitchFamily="34" charset="0"/>
+                <a:ea typeface="맑은 고딕" pitchFamily="34" charset="-122"/>
+                <a:cs typeface="맑은 고딕" pitchFamily="34" charset="-120"/>
+              </a:rPr>
+              <a:t>손해율은 업계 평균 수준으로, 성장 중심 지표에서 우위가 확인됨</a:t>
+            </a:r>
+            <a:endParaRPr lang="en-US" sz="1300" dirty="0"/>
+          </a:p>
+        </p:txBody>
+      </p:sp>
+      <p:sp>
+        <p:nvSpPr>
+          <p:cNvPr id="11" name="Shape 9"/>
+          <p:cNvSpPr/>
+          <p:nvPr/>
+        </p:nvSpPr>
+        <p:spPr>
+          <a:xfrm>
+            <a:off x="658368" y="2267712"/>
+            <a:ext cx="10881360" cy="365760"/>
+          </a:xfrm>
+          <a:prstGeom prst="rect">
+            <a:avLst/>
+          </a:prstGeom>
+          <a:solidFill>
+            <a:srgbClr val="0F1E5A"/>
+          </a:solidFill>
+          <a:ln/>
+        </p:spPr>
+      </p:sp>
+      <p:sp>
+        <p:nvSpPr>
+          <p:cNvPr id="12" name="Text 10"/>
+          <p:cNvSpPr/>
+          <p:nvPr/>
+        </p:nvSpPr>
+        <p:spPr>
+          <a:xfrm>
+            <a:off x="658368" y="2267712"/>
+            <a:ext cx="10881360" cy="365760"/>
+          </a:xfrm>
+          <a:prstGeom prst="rect">
+            <a:avLst/>
+          </a:prstGeom>
+          <a:noFill/>
+          <a:ln/>
+        </p:spPr>
+        <p:txBody>
+          <a:bodyPr wrap="square" lIns="0" tIns="0" rIns="0" bIns="0" rtlCol="0" anchor="ctr"/>
+          <a:lstStyle/>
+          <a:p>
+            <a:pPr algn="ctr" indent="0" marL="0">
+              <a:buNone/>
+            </a:pPr>
+            <a:r>
+              <a:rPr lang="en-US" sz="1300" b="1" dirty="0">
+                <a:solidFill>
+                  <a:srgbClr val="FFFFFF"/>
+                </a:solidFill>
+                <a:latin typeface="맑은 고딕" pitchFamily="34" charset="0"/>
+                <a:ea typeface="맑은 고딕" pitchFamily="34" charset="-122"/>
+                <a:cs typeface="맑은 고딕" pitchFamily="34" charset="-120"/>
+              </a:rPr>
+              <a:t>주요 지표 사별 비교 (예시)</a:t>
+            </a:r>
+            <a:endParaRPr lang="en-US" sz="1300" dirty="0"/>
+          </a:p>
+        </p:txBody>
+      </p:sp>
+      <p:sp>
+        <p:nvSpPr>
+          <p:cNvPr id="13" name="Shape 11"/>
+          <p:cNvSpPr/>
+          <p:nvPr/>
+        </p:nvSpPr>
+        <p:spPr>
+          <a:xfrm>
+            <a:off x="658368" y="2743200"/>
+            <a:ext cx="2377440" cy="457200"/>
+          </a:xfrm>
+          <a:prstGeom prst="rect">
+            <a:avLst/>
+          </a:prstGeom>
+          <a:solidFill>
+            <a:srgbClr val="0F1E5A"/>
+          </a:solidFill>
+          <a:ln w="9525">
+            <a:solidFill>
+              <a:srgbClr val="FFFFFF"/>
+            </a:solidFill>
+            <a:prstDash val="solid"/>
+          </a:ln>
+        </p:spPr>
+      </p:sp>
+      <p:sp>
+        <p:nvSpPr>
+          <p:cNvPr id="14" name="Text 12"/>
+          <p:cNvSpPr/>
+          <p:nvPr/>
+        </p:nvSpPr>
+        <p:spPr>
+          <a:xfrm>
+            <a:off x="658368" y="2743200"/>
+            <a:ext cx="2377440" cy="457200"/>
+          </a:xfrm>
+          <a:prstGeom prst="rect">
+            <a:avLst/>
+          </a:prstGeom>
+          <a:noFill/>
+          <a:ln/>
+        </p:spPr>
+        <p:txBody>
+          <a:bodyPr wrap="square" lIns="0" tIns="0" rIns="0" bIns="0" rtlCol="0" anchor="ctr"/>
+          <a:lstStyle/>
+          <a:p>
+            <a:pPr algn="ctr" indent="0" marL="0">
+              <a:buNone/>
+            </a:pPr>
+            <a:r>
+              <a:rPr lang="en-US" sz="1200" b="1" dirty="0">
+                <a:solidFill>
+                  <a:srgbClr val="FFFFFF"/>
+                </a:solidFill>
+                <a:latin typeface="맑은 고딕" pitchFamily="34" charset="0"/>
+                <a:ea typeface="맑은 고딕" pitchFamily="34" charset="-122"/>
+                <a:cs typeface="맑은 고딕" pitchFamily="34" charset="-120"/>
+              </a:rPr>
+              <a:t>구분</a:t>
+            </a:r>
+            <a:endParaRPr lang="en-US" sz="1200" dirty="0"/>
+          </a:p>
+        </p:txBody>
+      </p:sp>
+      <p:sp>
+        <p:nvSpPr>
+          <p:cNvPr id="15" name="Shape 13"/>
+          <p:cNvSpPr/>
+          <p:nvPr/>
+        </p:nvSpPr>
+        <p:spPr>
+          <a:xfrm>
+            <a:off x="3035808" y="2743200"/>
+            <a:ext cx="2125980" cy="457200"/>
+          </a:xfrm>
+          <a:prstGeom prst="rect">
+            <a:avLst/>
+          </a:prstGeom>
+          <a:solidFill>
+            <a:srgbClr val="1743E0"/>
+          </a:solidFill>
+          <a:ln w="9525">
+            <a:solidFill>
+              <a:srgbClr val="FFFFFF"/>
+            </a:solidFill>
+            <a:prstDash val="solid"/>
+          </a:ln>
+        </p:spPr>
+      </p:sp>
+      <p:sp>
+        <p:nvSpPr>
+          <p:cNvPr id="16" name="Text 14"/>
+          <p:cNvSpPr/>
+          <p:nvPr/>
+        </p:nvSpPr>
+        <p:spPr>
+          <a:xfrm>
+            <a:off x="3035808" y="2743200"/>
+            <a:ext cx="2125980" cy="457200"/>
+          </a:xfrm>
+          <a:prstGeom prst="rect">
+            <a:avLst/>
+          </a:prstGeom>
+          <a:noFill/>
+          <a:ln/>
+        </p:spPr>
+        <p:txBody>
+          <a:bodyPr wrap="square" lIns="0" tIns="0" rIns="0" bIns="0" rtlCol="0" anchor="ctr"/>
+          <a:lstStyle/>
+          <a:p>
+            <a:pPr algn="ctr" indent="0" marL="0">
+              <a:buNone/>
+            </a:pPr>
+            <a:r>
+              <a:rPr lang="en-US" sz="1150" b="1" dirty="0">
+                <a:solidFill>
+                  <a:srgbClr val="FFFFFF"/>
+                </a:solidFill>
+                <a:latin typeface="맑은 고딕" pitchFamily="34" charset="0"/>
+                <a:ea typeface="맑은 고딕" pitchFamily="34" charset="-122"/>
+                <a:cs typeface="맑은 고딕" pitchFamily="34" charset="-120"/>
+              </a:rPr>
+              <a:t>당사</a:t>
+            </a:r>
+            <a:endParaRPr lang="en-US" sz="1150" dirty="0"/>
+          </a:p>
+        </p:txBody>
+      </p:sp>
+      <p:sp>
+        <p:nvSpPr>
+          <p:cNvPr id="17" name="Shape 15"/>
+          <p:cNvSpPr/>
+          <p:nvPr/>
+        </p:nvSpPr>
+        <p:spPr>
+          <a:xfrm>
+            <a:off x="5161788" y="2743200"/>
+            <a:ext cx="2125980" cy="457200"/>
+          </a:xfrm>
+          <a:prstGeom prst="rect">
+            <a:avLst/>
+          </a:prstGeom>
+          <a:solidFill>
+            <a:srgbClr val="0F1E5A"/>
+          </a:solidFill>
+          <a:ln w="9525">
+            <a:solidFill>
+              <a:srgbClr val="FFFFFF"/>
+            </a:solidFill>
+            <a:prstDash val="solid"/>
+          </a:ln>
+        </p:spPr>
+      </p:sp>
+      <p:sp>
+        <p:nvSpPr>
+          <p:cNvPr id="18" name="Text 16"/>
+          <p:cNvSpPr/>
+          <p:nvPr/>
+        </p:nvSpPr>
+        <p:spPr>
+          <a:xfrm>
+            <a:off x="5161788" y="2743200"/>
+            <a:ext cx="2125980" cy="457200"/>
+          </a:xfrm>
+          <a:prstGeom prst="rect">
+            <a:avLst/>
+          </a:prstGeom>
+          <a:noFill/>
+          <a:ln/>
+        </p:spPr>
+        <p:txBody>
+          <a:bodyPr wrap="square" lIns="0" tIns="0" rIns="0" bIns="0" rtlCol="0" anchor="ctr"/>
+          <a:lstStyle/>
+          <a:p>
+            <a:pPr algn="ctr" indent="0" marL="0">
+              <a:buNone/>
+            </a:pPr>
+            <a:r>
+              <a:rPr lang="en-US" sz="1150" b="1" dirty="0">
+                <a:solidFill>
+                  <a:srgbClr val="FFFFFF"/>
+                </a:solidFill>
+                <a:latin typeface="맑은 고딕" pitchFamily="34" charset="0"/>
+                <a:ea typeface="맑은 고딕" pitchFamily="34" charset="-122"/>
+                <a:cs typeface="맑은 고딕" pitchFamily="34" charset="-120"/>
+              </a:rPr>
+              <a:t>A사</a:t>
+            </a:r>
+            <a:endParaRPr lang="en-US" sz="1150" dirty="0"/>
+          </a:p>
+        </p:txBody>
+      </p:sp>
+      <p:sp>
+        <p:nvSpPr>
+          <p:cNvPr id="19" name="Shape 17"/>
+          <p:cNvSpPr/>
+          <p:nvPr/>
+        </p:nvSpPr>
+        <p:spPr>
+          <a:xfrm>
+            <a:off x="7287768" y="2743200"/>
+            <a:ext cx="2125980" cy="457200"/>
+          </a:xfrm>
+          <a:prstGeom prst="rect">
+            <a:avLst/>
+          </a:prstGeom>
+          <a:solidFill>
+            <a:srgbClr val="0F1E5A"/>
+          </a:solidFill>
+          <a:ln w="9525">
+            <a:solidFill>
+              <a:srgbClr val="FFFFFF"/>
+            </a:solidFill>
+            <a:prstDash val="solid"/>
+          </a:ln>
+        </p:spPr>
+      </p:sp>
+      <p:sp>
+        <p:nvSpPr>
+          <p:cNvPr id="20" name="Text 18"/>
+          <p:cNvSpPr/>
+          <p:nvPr/>
+        </p:nvSpPr>
+        <p:spPr>
+          <a:xfrm>
+            <a:off x="7287768" y="2743200"/>
+            <a:ext cx="2125980" cy="457200"/>
+          </a:xfrm>
+          <a:prstGeom prst="rect">
+            <a:avLst/>
+          </a:prstGeom>
+          <a:noFill/>
+          <a:ln/>
+        </p:spPr>
+        <p:txBody>
+          <a:bodyPr wrap="square" lIns="0" tIns="0" rIns="0" bIns="0" rtlCol="0" anchor="ctr"/>
+          <a:lstStyle/>
+          <a:p>
+            <a:pPr algn="ctr" indent="0" marL="0">
+              <a:buNone/>
+            </a:pPr>
+            <a:r>
+              <a:rPr lang="en-US" sz="1150" b="1" dirty="0">
+                <a:solidFill>
+                  <a:srgbClr val="FFFFFF"/>
+                </a:solidFill>
+                <a:latin typeface="맑은 고딕" pitchFamily="34" charset="0"/>
+                <a:ea typeface="맑은 고딕" pitchFamily="34" charset="-122"/>
+                <a:cs typeface="맑은 고딕" pitchFamily="34" charset="-120"/>
+              </a:rPr>
+              <a:t>B사</a:t>
+            </a:r>
+            <a:endParaRPr lang="en-US" sz="1150" dirty="0"/>
+          </a:p>
+        </p:txBody>
+      </p:sp>
+      <p:sp>
+        <p:nvSpPr>
+          <p:cNvPr id="21" name="Shape 19"/>
+          <p:cNvSpPr/>
+          <p:nvPr/>
+        </p:nvSpPr>
+        <p:spPr>
+          <a:xfrm>
+            <a:off x="9413748" y="2743200"/>
+            <a:ext cx="2125980" cy="457200"/>
+          </a:xfrm>
+          <a:prstGeom prst="rect">
+            <a:avLst/>
+          </a:prstGeom>
+          <a:solidFill>
+            <a:srgbClr val="0F1E5A"/>
+          </a:solidFill>
+          <a:ln w="9525">
+            <a:solidFill>
+              <a:srgbClr val="FFFFFF"/>
+            </a:solidFill>
+            <a:prstDash val="solid"/>
+          </a:ln>
+        </p:spPr>
+      </p:sp>
+      <p:sp>
+        <p:nvSpPr>
+          <p:cNvPr id="22" name="Text 20"/>
+          <p:cNvSpPr/>
+          <p:nvPr/>
+        </p:nvSpPr>
+        <p:spPr>
+          <a:xfrm>
+            <a:off x="9413748" y="2743200"/>
+            <a:ext cx="2125980" cy="457200"/>
+          </a:xfrm>
+          <a:prstGeom prst="rect">
+            <a:avLst/>
+          </a:prstGeom>
+          <a:noFill/>
+          <a:ln/>
+        </p:spPr>
+        <p:txBody>
+          <a:bodyPr wrap="square" lIns="0" tIns="0" rIns="0" bIns="0" rtlCol="0" anchor="ctr"/>
+          <a:lstStyle/>
+          <a:p>
+            <a:pPr algn="ctr" indent="0" marL="0">
+              <a:buNone/>
+            </a:pPr>
+            <a:r>
+              <a:rPr lang="en-US" sz="1150" b="1" dirty="0">
+                <a:solidFill>
+                  <a:srgbClr val="FFFFFF"/>
+                </a:solidFill>
+                <a:latin typeface="맑은 고딕" pitchFamily="34" charset="0"/>
+                <a:ea typeface="맑은 고딕" pitchFamily="34" charset="-122"/>
+                <a:cs typeface="맑은 고딕" pitchFamily="34" charset="-120"/>
+              </a:rPr>
+              <a:t>C사</a:t>
+            </a:r>
+            <a:endParaRPr lang="en-US" sz="1150" dirty="0"/>
+          </a:p>
+        </p:txBody>
+      </p:sp>
+      <p:sp>
+        <p:nvSpPr>
+          <p:cNvPr id="23" name="Shape 21"/>
+          <p:cNvSpPr/>
+          <p:nvPr/>
+        </p:nvSpPr>
+        <p:spPr>
+          <a:xfrm>
+            <a:off x="658368" y="3200400"/>
+            <a:ext cx="2377440" cy="822960"/>
+          </a:xfrm>
+          <a:prstGeom prst="rect">
+            <a:avLst/>
+          </a:prstGeom>
+          <a:solidFill>
+            <a:srgbClr val="ECEFF3"/>
+          </a:solidFill>
+          <a:ln w="9525">
+            <a:solidFill>
+              <a:srgbClr val="D8DDE6"/>
+            </a:solidFill>
+            <a:prstDash val="solid"/>
+          </a:ln>
+        </p:spPr>
+      </p:sp>
+      <p:sp>
+        <p:nvSpPr>
+          <p:cNvPr id="24" name="Text 22"/>
+          <p:cNvSpPr/>
+          <p:nvPr/>
+        </p:nvSpPr>
+        <p:spPr>
+          <a:xfrm>
+            <a:off x="795528" y="3200400"/>
+            <a:ext cx="2103120" cy="822960"/>
+          </a:xfrm>
+          <a:prstGeom prst="rect">
+            <a:avLst/>
+          </a:prstGeom>
+          <a:noFill/>
+          <a:ln/>
+        </p:spPr>
+        <p:txBody>
+          <a:bodyPr wrap="square" lIns="0" tIns="0" rIns="0" bIns="0" rtlCol="0" anchor="ctr"/>
+          <a:lstStyle/>
+          <a:p>
+            <a:pPr algn="l" indent="0" marL="0">
+              <a:buNone/>
+            </a:pPr>
+            <a:r>
+              <a:rPr lang="en-US" sz="1200" b="1" dirty="0">
+                <a:solidFill>
+                  <a:srgbClr val="1F2A44"/>
+                </a:solidFill>
+                <a:latin typeface="맑은 고딕" pitchFamily="34" charset="0"/>
+                <a:ea typeface="맑은 고딕" pitchFamily="34" charset="-122"/>
+                <a:cs typeface="맑은 고딕" pitchFamily="34" charset="-120"/>
+              </a:rPr>
+              <a:t>신계약 성장률</a:t>
+            </a:r>
+            <a:endParaRPr lang="en-US" sz="1200" dirty="0"/>
+          </a:p>
+        </p:txBody>
+      </p:sp>
+      <p:sp>
+        <p:nvSpPr>
+          <p:cNvPr id="25" name="Shape 23"/>
+          <p:cNvSpPr/>
+          <p:nvPr/>
+        </p:nvSpPr>
+        <p:spPr>
+          <a:xfrm>
+            <a:off x="3035808" y="3200400"/>
+            <a:ext cx="2125980" cy="822960"/>
+          </a:xfrm>
+          <a:prstGeom prst="rect">
+            <a:avLst/>
+          </a:prstGeom>
+          <a:solidFill>
+            <a:srgbClr val="E9EFFD"/>
+          </a:solidFill>
+          <a:ln w="9525">
+            <a:solidFill>
+              <a:srgbClr val="D8DDE6"/>
+            </a:solidFill>
+            <a:prstDash val="solid"/>
+          </a:ln>
+        </p:spPr>
+      </p:sp>
+      <p:sp>
+        <p:nvSpPr>
+          <p:cNvPr id="26" name="Text 24"/>
+          <p:cNvSpPr/>
+          <p:nvPr/>
+        </p:nvSpPr>
+        <p:spPr>
+          <a:xfrm>
+            <a:off x="3108960" y="3200400"/>
+            <a:ext cx="1979676" cy="822960"/>
+          </a:xfrm>
+          <a:prstGeom prst="rect">
+            <a:avLst/>
+          </a:prstGeom>
+          <a:noFill/>
+          <a:ln/>
+        </p:spPr>
+        <p:txBody>
+          <a:bodyPr wrap="square" lIns="0" tIns="0" rIns="0" bIns="0" rtlCol="0" anchor="ctr"/>
+          <a:lstStyle/>
+          <a:p>
+            <a:pPr algn="ctr" indent="0" marL="0">
+              <a:buNone/>
+            </a:pPr>
+            <a:r>
+              <a:rPr lang="en-US" sz="1150" b="1" dirty="0">
+                <a:solidFill>
+                  <a:srgbClr val="0E8A6A"/>
+                </a:solidFill>
+                <a:latin typeface="맑은 고딕" pitchFamily="34" charset="0"/>
+                <a:ea typeface="맑은 고딕" pitchFamily="34" charset="-122"/>
+                <a:cs typeface="맑은 고딕" pitchFamily="34" charset="-120"/>
+              </a:rPr>
+              <a:t>+18%</a:t>
+            </a:r>
+            <a:endParaRPr lang="en-US" sz="1150" dirty="0"/>
+          </a:p>
+        </p:txBody>
+      </p:sp>
+      <p:sp>
+        <p:nvSpPr>
+          <p:cNvPr id="27" name="Shape 25"/>
+          <p:cNvSpPr/>
+          <p:nvPr/>
+        </p:nvSpPr>
+        <p:spPr>
+          <a:xfrm>
+            <a:off x="5161788" y="3200400"/>
+            <a:ext cx="2125980" cy="822960"/>
+          </a:xfrm>
+          <a:prstGeom prst="rect">
+            <a:avLst/>
+          </a:prstGeom>
+          <a:solidFill>
+            <a:srgbClr val="FFFFFF"/>
+          </a:solidFill>
+          <a:ln w="9525">
+            <a:solidFill>
+              <a:srgbClr val="D8DDE6"/>
+            </a:solidFill>
+            <a:prstDash val="solid"/>
+          </a:ln>
+        </p:spPr>
+      </p:sp>
+      <p:sp>
+        <p:nvSpPr>
+          <p:cNvPr id="28" name="Text 26"/>
+          <p:cNvSpPr/>
+          <p:nvPr/>
+        </p:nvSpPr>
+        <p:spPr>
+          <a:xfrm>
+            <a:off x="5234940" y="3200400"/>
+            <a:ext cx="1979676" cy="822960"/>
+          </a:xfrm>
+          <a:prstGeom prst="rect">
+            <a:avLst/>
+          </a:prstGeom>
+          <a:noFill/>
+          <a:ln/>
+        </p:spPr>
+        <p:txBody>
+          <a:bodyPr wrap="square" lIns="0" tIns="0" rIns="0" bIns="0" rtlCol="0" anchor="ctr"/>
+          <a:lstStyle/>
+          <a:p>
+            <a:pPr algn="ctr" indent="0" marL="0">
+              <a:buNone/>
+            </a:pPr>
+            <a:r>
+              <a:rPr lang="en-US" sz="1150" dirty="0">
+                <a:solidFill>
+                  <a:srgbClr val="1F2A44"/>
+                </a:solidFill>
+                <a:latin typeface="맑은 고딕" pitchFamily="34" charset="0"/>
+                <a:ea typeface="맑은 고딕" pitchFamily="34" charset="-122"/>
+                <a:cs typeface="맑은 고딕" pitchFamily="34" charset="-120"/>
+              </a:rPr>
+              <a:t>+9%</a:t>
+            </a:r>
+            <a:endParaRPr lang="en-US" sz="1150" dirty="0"/>
+          </a:p>
+        </p:txBody>
+      </p:sp>
+      <p:sp>
+        <p:nvSpPr>
+          <p:cNvPr id="29" name="Shape 27"/>
+          <p:cNvSpPr/>
+          <p:nvPr/>
+        </p:nvSpPr>
+        <p:spPr>
+          <a:xfrm>
+            <a:off x="7287768" y="3200400"/>
+            <a:ext cx="2125980" cy="822960"/>
+          </a:xfrm>
+          <a:prstGeom prst="rect">
+            <a:avLst/>
+          </a:prstGeom>
+          <a:solidFill>
+            <a:srgbClr val="FFFFFF"/>
+          </a:solidFill>
+          <a:ln w="9525">
+            <a:solidFill>
+              <a:srgbClr val="D8DDE6"/>
+            </a:solidFill>
+            <a:prstDash val="solid"/>
+          </a:ln>
+        </p:spPr>
+      </p:sp>
+      <p:sp>
+        <p:nvSpPr>
+          <p:cNvPr id="30" name="Text 28"/>
+          <p:cNvSpPr/>
+          <p:nvPr/>
+        </p:nvSpPr>
+        <p:spPr>
+          <a:xfrm>
+            <a:off x="7360920" y="3200400"/>
+            <a:ext cx="1979676" cy="822960"/>
+          </a:xfrm>
+          <a:prstGeom prst="rect">
+            <a:avLst/>
+          </a:prstGeom>
+          <a:noFill/>
+          <a:ln/>
+        </p:spPr>
+        <p:txBody>
+          <a:bodyPr wrap="square" lIns="0" tIns="0" rIns="0" bIns="0" rtlCol="0" anchor="ctr"/>
+          <a:lstStyle/>
+          <a:p>
+            <a:pPr algn="ctr" indent="0" marL="0">
+              <a:buNone/>
+            </a:pPr>
+            <a:r>
+              <a:rPr lang="en-US" sz="1150" dirty="0">
+                <a:solidFill>
+                  <a:srgbClr val="1F2A44"/>
+                </a:solidFill>
+                <a:latin typeface="맑은 고딕" pitchFamily="34" charset="0"/>
+                <a:ea typeface="맑은 고딕" pitchFamily="34" charset="-122"/>
+                <a:cs typeface="맑은 고딕" pitchFamily="34" charset="-120"/>
+              </a:rPr>
+              <a:t>+12%</a:t>
+            </a:r>
+            <a:endParaRPr lang="en-US" sz="1150" dirty="0"/>
+          </a:p>
+        </p:txBody>
+      </p:sp>
+      <p:sp>
+        <p:nvSpPr>
+          <p:cNvPr id="31" name="Shape 29"/>
+          <p:cNvSpPr/>
+          <p:nvPr/>
+        </p:nvSpPr>
+        <p:spPr>
+          <a:xfrm>
+            <a:off x="9413748" y="3200400"/>
+            <a:ext cx="2125980" cy="822960"/>
+          </a:xfrm>
+          <a:prstGeom prst="rect">
+            <a:avLst/>
+          </a:prstGeom>
+          <a:solidFill>
+            <a:srgbClr val="FFFFFF"/>
+          </a:solidFill>
+          <a:ln w="9525">
+            <a:solidFill>
+              <a:srgbClr val="D8DDE6"/>
+            </a:solidFill>
+            <a:prstDash val="solid"/>
+          </a:ln>
+        </p:spPr>
+      </p:sp>
+      <p:sp>
+        <p:nvSpPr>
+          <p:cNvPr id="32" name="Text 30"/>
+          <p:cNvSpPr/>
+          <p:nvPr/>
+        </p:nvSpPr>
+        <p:spPr>
+          <a:xfrm>
+            <a:off x="9486900" y="3200400"/>
+            <a:ext cx="1979676" cy="822960"/>
+          </a:xfrm>
+          <a:prstGeom prst="rect">
+            <a:avLst/>
+          </a:prstGeom>
+          <a:noFill/>
+          <a:ln/>
+        </p:spPr>
+        <p:txBody>
+          <a:bodyPr wrap="square" lIns="0" tIns="0" rIns="0" bIns="0" rtlCol="0" anchor="ctr"/>
+          <a:lstStyle/>
+          <a:p>
+            <a:pPr algn="ctr" indent="0" marL="0">
+              <a:buNone/>
+            </a:pPr>
+            <a:r>
+              <a:rPr lang="en-US" sz="1150" dirty="0">
+                <a:solidFill>
+                  <a:srgbClr val="1F2A44"/>
+                </a:solidFill>
+                <a:latin typeface="맑은 고딕" pitchFamily="34" charset="0"/>
+                <a:ea typeface="맑은 고딕" pitchFamily="34" charset="-122"/>
+                <a:cs typeface="맑은 고딕" pitchFamily="34" charset="-120"/>
+              </a:rPr>
+              <a:t>+4%</a:t>
+            </a:r>
+            <a:endParaRPr lang="en-US" sz="1150" dirty="0"/>
+          </a:p>
+        </p:txBody>
+      </p:sp>
+      <p:sp>
+        <p:nvSpPr>
+          <p:cNvPr id="33" name="Shape 31"/>
+          <p:cNvSpPr/>
+          <p:nvPr/>
+        </p:nvSpPr>
+        <p:spPr>
+          <a:xfrm>
+            <a:off x="658368" y="4023360"/>
+            <a:ext cx="2377440" cy="822960"/>
+          </a:xfrm>
+          <a:prstGeom prst="rect">
+            <a:avLst/>
+          </a:prstGeom>
+          <a:solidFill>
+            <a:srgbClr val="ECEFF3"/>
+          </a:solidFill>
+          <a:ln w="9525">
+            <a:solidFill>
+              <a:srgbClr val="D8DDE6"/>
+            </a:solidFill>
+            <a:prstDash val="solid"/>
+          </a:ln>
+        </p:spPr>
+      </p:sp>
+      <p:sp>
+        <p:nvSpPr>
+          <p:cNvPr id="34" name="Text 32"/>
+          <p:cNvSpPr/>
+          <p:nvPr/>
+        </p:nvSpPr>
+        <p:spPr>
+          <a:xfrm>
+            <a:off x="795528" y="4023360"/>
+            <a:ext cx="2103120" cy="822960"/>
+          </a:xfrm>
+          <a:prstGeom prst="rect">
+            <a:avLst/>
+          </a:prstGeom>
+          <a:noFill/>
+          <a:ln/>
+        </p:spPr>
+        <p:txBody>
+          <a:bodyPr wrap="square" lIns="0" tIns="0" rIns="0" bIns="0" rtlCol="0" anchor="ctr"/>
+          <a:lstStyle/>
+          <a:p>
+            <a:pPr algn="l" indent="0" marL="0">
+              <a:buNone/>
+            </a:pPr>
+            <a:r>
+              <a:rPr lang="en-US" sz="1200" b="1" dirty="0">
+                <a:solidFill>
+                  <a:srgbClr val="1F2A44"/>
+                </a:solidFill>
+                <a:latin typeface="맑은 고딕" pitchFamily="34" charset="0"/>
+                <a:ea typeface="맑은 고딕" pitchFamily="34" charset="-122"/>
+                <a:cs typeface="맑은 고딕" pitchFamily="34" charset="-120"/>
+              </a:rPr>
+              <a:t>13회차 유지율</a:t>
+            </a:r>
+            <a:endParaRPr lang="en-US" sz="1200" dirty="0"/>
+          </a:p>
+        </p:txBody>
+      </p:sp>
+      <p:sp>
+        <p:nvSpPr>
+          <p:cNvPr id="35" name="Shape 33"/>
+          <p:cNvSpPr/>
+          <p:nvPr/>
+        </p:nvSpPr>
+        <p:spPr>
+          <a:xfrm>
+            <a:off x="3035808" y="4023360"/>
+            <a:ext cx="2125980" cy="822960"/>
+          </a:xfrm>
+          <a:prstGeom prst="rect">
+            <a:avLst/>
+          </a:prstGeom>
+          <a:solidFill>
+            <a:srgbClr val="E9EFFD"/>
+          </a:solidFill>
+          <a:ln w="9525">
+            <a:solidFill>
+              <a:srgbClr val="D8DDE6"/>
+            </a:solidFill>
+            <a:prstDash val="solid"/>
+          </a:ln>
+        </p:spPr>
+      </p:sp>
+      <p:sp>
+        <p:nvSpPr>
+          <p:cNvPr id="36" name="Text 34"/>
+          <p:cNvSpPr/>
+          <p:nvPr/>
+        </p:nvSpPr>
+        <p:spPr>
+          <a:xfrm>
+            <a:off x="3108960" y="4023360"/>
+            <a:ext cx="1979676" cy="822960"/>
+          </a:xfrm>
+          <a:prstGeom prst="rect">
+            <a:avLst/>
+          </a:prstGeom>
+          <a:noFill/>
+          <a:ln/>
+        </p:spPr>
+        <p:txBody>
+          <a:bodyPr wrap="square" lIns="0" tIns="0" rIns="0" bIns="0" rtlCol="0" anchor="ctr"/>
+          <a:lstStyle/>
+          <a:p>
+            <a:pPr algn="ctr" indent="0" marL="0">
+              <a:buNone/>
+            </a:pPr>
+            <a:r>
+              <a:rPr lang="en-US" sz="1150" b="1" dirty="0">
+                <a:solidFill>
+                  <a:srgbClr val="0E8A6A"/>
+                </a:solidFill>
+                <a:latin typeface="맑은 고딕" pitchFamily="34" charset="0"/>
+                <a:ea typeface="맑은 고딕" pitchFamily="34" charset="-122"/>
+                <a:cs typeface="맑은 고딕" pitchFamily="34" charset="-120"/>
+              </a:rPr>
+              <a:t>87%</a:t>
+            </a:r>
+            <a:endParaRPr lang="en-US" sz="1150" dirty="0"/>
+          </a:p>
+        </p:txBody>
+      </p:sp>
+      <p:sp>
+        <p:nvSpPr>
+          <p:cNvPr id="37" name="Shape 35"/>
+          <p:cNvSpPr/>
+          <p:nvPr/>
+        </p:nvSpPr>
+        <p:spPr>
+          <a:xfrm>
+            <a:off x="5161788" y="4023360"/>
+            <a:ext cx="2125980" cy="822960"/>
+          </a:xfrm>
+          <a:prstGeom prst="rect">
+            <a:avLst/>
+          </a:prstGeom>
+          <a:solidFill>
+            <a:srgbClr val="FFFFFF"/>
+          </a:solidFill>
+          <a:ln w="9525">
+            <a:solidFill>
+              <a:srgbClr val="D8DDE6"/>
+            </a:solidFill>
+            <a:prstDash val="solid"/>
+          </a:ln>
+        </p:spPr>
+      </p:sp>
+      <p:sp>
+        <p:nvSpPr>
+          <p:cNvPr id="38" name="Text 36"/>
+          <p:cNvSpPr/>
+          <p:nvPr/>
+        </p:nvSpPr>
+        <p:spPr>
+          <a:xfrm>
+            <a:off x="5234940" y="4023360"/>
+            <a:ext cx="1979676" cy="822960"/>
+          </a:xfrm>
+          <a:prstGeom prst="rect">
+            <a:avLst/>
+          </a:prstGeom>
+          <a:noFill/>
+          <a:ln/>
+        </p:spPr>
+        <p:txBody>
+          <a:bodyPr wrap="square" lIns="0" tIns="0" rIns="0" bIns="0" rtlCol="0" anchor="ctr"/>
+          <a:lstStyle/>
+          <a:p>
+            <a:pPr algn="ctr" indent="0" marL="0">
+              <a:buNone/>
+            </a:pPr>
+            <a:r>
+              <a:rPr lang="en-US" sz="1150" dirty="0">
+                <a:solidFill>
+                  <a:srgbClr val="1F2A44"/>
+                </a:solidFill>
+                <a:latin typeface="맑은 고딕" pitchFamily="34" charset="0"/>
+                <a:ea typeface="맑은 고딕" pitchFamily="34" charset="-122"/>
+                <a:cs typeface="맑은 고딕" pitchFamily="34" charset="-120"/>
+              </a:rPr>
+              <a:t>84%</a:t>
+            </a:r>
+            <a:endParaRPr lang="en-US" sz="1150" dirty="0"/>
+          </a:p>
+        </p:txBody>
+      </p:sp>
+      <p:sp>
+        <p:nvSpPr>
+          <p:cNvPr id="39" name="Shape 37"/>
+          <p:cNvSpPr/>
+          <p:nvPr/>
+        </p:nvSpPr>
+        <p:spPr>
+          <a:xfrm>
+            <a:off x="7287768" y="4023360"/>
+            <a:ext cx="2125980" cy="822960"/>
+          </a:xfrm>
+          <a:prstGeom prst="rect">
+            <a:avLst/>
+          </a:prstGeom>
+          <a:solidFill>
+            <a:srgbClr val="FFFFFF"/>
+          </a:solidFill>
+          <a:ln w="9525">
+            <a:solidFill>
+              <a:srgbClr val="D8DDE6"/>
+            </a:solidFill>
+            <a:prstDash val="solid"/>
+          </a:ln>
+        </p:spPr>
+      </p:sp>
+      <p:sp>
+        <p:nvSpPr>
+          <p:cNvPr id="40" name="Text 38"/>
+          <p:cNvSpPr/>
+          <p:nvPr/>
+        </p:nvSpPr>
+        <p:spPr>
+          <a:xfrm>
+            <a:off x="7360920" y="4023360"/>
+            <a:ext cx="1979676" cy="822960"/>
+          </a:xfrm>
+          <a:prstGeom prst="rect">
+            <a:avLst/>
+          </a:prstGeom>
+          <a:noFill/>
+          <a:ln/>
+        </p:spPr>
+        <p:txBody>
+          <a:bodyPr wrap="square" lIns="0" tIns="0" rIns="0" bIns="0" rtlCol="0" anchor="ctr"/>
+          <a:lstStyle/>
+          <a:p>
+            <a:pPr algn="ctr" indent="0" marL="0">
+              <a:buNone/>
+            </a:pPr>
+            <a:r>
+              <a:rPr lang="en-US" sz="1150" dirty="0">
+                <a:solidFill>
+                  <a:srgbClr val="1F2A44"/>
+                </a:solidFill>
+                <a:latin typeface="맑은 고딕" pitchFamily="34" charset="0"/>
+                <a:ea typeface="맑은 고딕" pitchFamily="34" charset="-122"/>
+                <a:cs typeface="맑은 고딕" pitchFamily="34" charset="-120"/>
+              </a:rPr>
+              <a:t>81%</a:t>
+            </a:r>
+            <a:endParaRPr lang="en-US" sz="1150" dirty="0"/>
+          </a:p>
+        </p:txBody>
+      </p:sp>
+      <p:sp>
+        <p:nvSpPr>
+          <p:cNvPr id="41" name="Shape 39"/>
+          <p:cNvSpPr/>
+          <p:nvPr/>
+        </p:nvSpPr>
+        <p:spPr>
+          <a:xfrm>
+            <a:off x="9413748" y="4023360"/>
+            <a:ext cx="2125980" cy="822960"/>
+          </a:xfrm>
+          <a:prstGeom prst="rect">
+            <a:avLst/>
+          </a:prstGeom>
+          <a:solidFill>
+            <a:srgbClr val="FFFFFF"/>
+          </a:solidFill>
+          <a:ln w="9525">
+            <a:solidFill>
+              <a:srgbClr val="D8DDE6"/>
+            </a:solidFill>
+            <a:prstDash val="solid"/>
+          </a:ln>
+        </p:spPr>
+      </p:sp>
+      <p:sp>
+        <p:nvSpPr>
+          <p:cNvPr id="42" name="Text 40"/>
+          <p:cNvSpPr/>
+          <p:nvPr/>
+        </p:nvSpPr>
+        <p:spPr>
+          <a:xfrm>
+            <a:off x="9486900" y="4023360"/>
+            <a:ext cx="1979676" cy="822960"/>
+          </a:xfrm>
+          <a:prstGeom prst="rect">
+            <a:avLst/>
+          </a:prstGeom>
+          <a:noFill/>
+          <a:ln/>
+        </p:spPr>
+        <p:txBody>
+          <a:bodyPr wrap="square" lIns="0" tIns="0" rIns="0" bIns="0" rtlCol="0" anchor="ctr"/>
+          <a:lstStyle/>
+          <a:p>
+            <a:pPr algn="ctr" indent="0" marL="0">
+              <a:buNone/>
+            </a:pPr>
+            <a:r>
+              <a:rPr lang="en-US" sz="1150" dirty="0">
+                <a:solidFill>
+                  <a:srgbClr val="1F2A44"/>
+                </a:solidFill>
+                <a:latin typeface="맑은 고딕" pitchFamily="34" charset="0"/>
+                <a:ea typeface="맑은 고딕" pitchFamily="34" charset="-122"/>
+                <a:cs typeface="맑은 고딕" pitchFamily="34" charset="-120"/>
+              </a:rPr>
+              <a:t>85%</a:t>
+            </a:r>
+            <a:endParaRPr lang="en-US" sz="1150" dirty="0"/>
+          </a:p>
+        </p:txBody>
+      </p:sp>
+      <p:sp>
+        <p:nvSpPr>
+          <p:cNvPr id="43" name="Shape 41"/>
+          <p:cNvSpPr/>
+          <p:nvPr/>
+        </p:nvSpPr>
+        <p:spPr>
+          <a:xfrm>
+            <a:off x="658368" y="4846320"/>
+            <a:ext cx="2377440" cy="822960"/>
+          </a:xfrm>
+          <a:prstGeom prst="rect">
+            <a:avLst/>
+          </a:prstGeom>
+          <a:solidFill>
+            <a:srgbClr val="ECEFF3"/>
+          </a:solidFill>
+          <a:ln w="9525">
+            <a:solidFill>
+              <a:srgbClr val="D8DDE6"/>
+            </a:solidFill>
+            <a:prstDash val="solid"/>
+          </a:ln>
+        </p:spPr>
+      </p:sp>
+      <p:sp>
+        <p:nvSpPr>
+          <p:cNvPr id="44" name="Text 42"/>
+          <p:cNvSpPr/>
+          <p:nvPr/>
+        </p:nvSpPr>
+        <p:spPr>
+          <a:xfrm>
+            <a:off x="795528" y="4846320"/>
+            <a:ext cx="2103120" cy="822960"/>
+          </a:xfrm>
+          <a:prstGeom prst="rect">
+            <a:avLst/>
+          </a:prstGeom>
+          <a:noFill/>
+          <a:ln/>
+        </p:spPr>
+        <p:txBody>
+          <a:bodyPr wrap="square" lIns="0" tIns="0" rIns="0" bIns="0" rtlCol="0" anchor="ctr"/>
+          <a:lstStyle/>
+          <a:p>
+            <a:pPr algn="l" indent="0" marL="0">
+              <a:buNone/>
+            </a:pPr>
+            <a:r>
+              <a:rPr lang="en-US" sz="1200" b="1" dirty="0">
+                <a:solidFill>
+                  <a:srgbClr val="1F2A44"/>
+                </a:solidFill>
+                <a:latin typeface="맑은 고딕" pitchFamily="34" charset="0"/>
+                <a:ea typeface="맑은 고딕" pitchFamily="34" charset="-122"/>
+                <a:cs typeface="맑은 고딕" pitchFamily="34" charset="-120"/>
+              </a:rPr>
+              <a:t>손해율</a:t>
+            </a:r>
+            <a:endParaRPr lang="en-US" sz="1200" dirty="0"/>
+          </a:p>
+        </p:txBody>
+      </p:sp>
+      <p:sp>
+        <p:nvSpPr>
+          <p:cNvPr id="45" name="Shape 43"/>
+          <p:cNvSpPr/>
+          <p:nvPr/>
+        </p:nvSpPr>
+        <p:spPr>
+          <a:xfrm>
+            <a:off x="3035808" y="4846320"/>
+            <a:ext cx="2125980" cy="822960"/>
+          </a:xfrm>
+          <a:prstGeom prst="rect">
+            <a:avLst/>
+          </a:prstGeom>
+          <a:solidFill>
+            <a:srgbClr val="E9EFFD"/>
+          </a:solidFill>
+          <a:ln w="9525">
+            <a:solidFill>
+              <a:srgbClr val="D8DDE6"/>
+            </a:solidFill>
+            <a:prstDash val="solid"/>
+          </a:ln>
+        </p:spPr>
+      </p:sp>
+      <p:sp>
+        <p:nvSpPr>
+          <p:cNvPr id="46" name="Text 44"/>
+          <p:cNvSpPr/>
+          <p:nvPr/>
+        </p:nvSpPr>
+        <p:spPr>
+          <a:xfrm>
+            <a:off x="3108960" y="4846320"/>
+            <a:ext cx="1979676" cy="822960"/>
+          </a:xfrm>
+          <a:prstGeom prst="rect">
+            <a:avLst/>
+          </a:prstGeom>
+          <a:noFill/>
+          <a:ln/>
+        </p:spPr>
+        <p:txBody>
+          <a:bodyPr wrap="square" lIns="0" tIns="0" rIns="0" bIns="0" rtlCol="0" anchor="ctr"/>
+          <a:lstStyle/>
+          <a:p>
+            <a:pPr algn="ctr" indent="0" marL="0">
+              <a:buNone/>
+            </a:pPr>
+            <a:r>
+              <a:rPr lang="en-US" sz="1150" dirty="0">
+                <a:solidFill>
+                  <a:srgbClr val="1F2A44"/>
+                </a:solidFill>
+                <a:latin typeface="맑은 고딕" pitchFamily="34" charset="0"/>
+                <a:ea typeface="맑은 고딕" pitchFamily="34" charset="-122"/>
+                <a:cs typeface="맑은 고딕" pitchFamily="34" charset="-120"/>
+              </a:rPr>
+              <a:t>85%</a:t>
+            </a:r>
+            <a:endParaRPr lang="en-US" sz="1150" dirty="0"/>
+          </a:p>
+        </p:txBody>
+      </p:sp>
+      <p:sp>
+        <p:nvSpPr>
+          <p:cNvPr id="47" name="Shape 45"/>
+          <p:cNvSpPr/>
+          <p:nvPr/>
+        </p:nvSpPr>
+        <p:spPr>
+          <a:xfrm>
+            <a:off x="5161788" y="4846320"/>
+            <a:ext cx="2125980" cy="822960"/>
+          </a:xfrm>
+          <a:prstGeom prst="rect">
+            <a:avLst/>
+          </a:prstGeom>
+          <a:solidFill>
+            <a:srgbClr val="FFFFFF"/>
+          </a:solidFill>
+          <a:ln w="9525">
+            <a:solidFill>
+              <a:srgbClr val="D8DDE6"/>
+            </a:solidFill>
+            <a:prstDash val="solid"/>
+          </a:ln>
+        </p:spPr>
+      </p:sp>
+      <p:sp>
+        <p:nvSpPr>
+          <p:cNvPr id="48" name="Text 46"/>
+          <p:cNvSpPr/>
+          <p:nvPr/>
+        </p:nvSpPr>
+        <p:spPr>
+          <a:xfrm>
+            <a:off x="5234940" y="4846320"/>
+            <a:ext cx="1979676" cy="822960"/>
+          </a:xfrm>
+          <a:prstGeom prst="rect">
+            <a:avLst/>
+          </a:prstGeom>
+          <a:noFill/>
+          <a:ln/>
+        </p:spPr>
+        <p:txBody>
+          <a:bodyPr wrap="square" lIns="0" tIns="0" rIns="0" bIns="0" rtlCol="0" anchor="ctr"/>
+          <a:lstStyle/>
+          <a:p>
+            <a:pPr algn="ctr" indent="0" marL="0">
+              <a:buNone/>
+            </a:pPr>
+            <a:r>
+              <a:rPr lang="en-US" sz="1150" dirty="0">
+                <a:solidFill>
+                  <a:srgbClr val="1F2A44"/>
+                </a:solidFill>
+                <a:latin typeface="맑은 고딕" pitchFamily="34" charset="0"/>
+                <a:ea typeface="맑은 고딕" pitchFamily="34" charset="-122"/>
+                <a:cs typeface="맑은 고딕" pitchFamily="34" charset="-120"/>
+              </a:rPr>
+              <a:t>83%</a:t>
+            </a:r>
+            <a:endParaRPr lang="en-US" sz="1150" dirty="0"/>
+          </a:p>
+        </p:txBody>
+      </p:sp>
+      <p:sp>
+        <p:nvSpPr>
+          <p:cNvPr id="49" name="Shape 47"/>
+          <p:cNvSpPr/>
+          <p:nvPr/>
+        </p:nvSpPr>
+        <p:spPr>
+          <a:xfrm>
+            <a:off x="7287768" y="4846320"/>
+            <a:ext cx="2125980" cy="822960"/>
+          </a:xfrm>
+          <a:prstGeom prst="rect">
+            <a:avLst/>
+          </a:prstGeom>
+          <a:solidFill>
+            <a:srgbClr val="FFFFFF"/>
+          </a:solidFill>
+          <a:ln w="9525">
+            <a:solidFill>
+              <a:srgbClr val="D8DDE6"/>
+            </a:solidFill>
+            <a:prstDash val="solid"/>
+          </a:ln>
+        </p:spPr>
+      </p:sp>
+      <p:sp>
+        <p:nvSpPr>
+          <p:cNvPr id="50" name="Text 48"/>
+          <p:cNvSpPr/>
+          <p:nvPr/>
+        </p:nvSpPr>
+        <p:spPr>
+          <a:xfrm>
+            <a:off x="7360920" y="4846320"/>
+            <a:ext cx="1979676" cy="822960"/>
+          </a:xfrm>
+          <a:prstGeom prst="rect">
+            <a:avLst/>
+          </a:prstGeom>
+          <a:noFill/>
+          <a:ln/>
+        </p:spPr>
+        <p:txBody>
+          <a:bodyPr wrap="square" lIns="0" tIns="0" rIns="0" bIns="0" rtlCol="0" anchor="ctr"/>
+          <a:lstStyle/>
+          <a:p>
+            <a:pPr algn="ctr" indent="0" marL="0">
+              <a:buNone/>
+            </a:pPr>
+            <a:r>
+              <a:rPr lang="en-US" sz="1150" dirty="0">
+                <a:solidFill>
+                  <a:srgbClr val="1F2A44"/>
+                </a:solidFill>
+                <a:latin typeface="맑은 고딕" pitchFamily="34" charset="0"/>
+                <a:ea typeface="맑은 고딕" pitchFamily="34" charset="-122"/>
+                <a:cs typeface="맑은 고딕" pitchFamily="34" charset="-120"/>
+              </a:rPr>
+              <a:t>88%</a:t>
+            </a:r>
+            <a:endParaRPr lang="en-US" sz="1150" dirty="0"/>
+          </a:p>
+        </p:txBody>
+      </p:sp>
+      <p:sp>
+        <p:nvSpPr>
+          <p:cNvPr id="51" name="Shape 49"/>
+          <p:cNvSpPr/>
+          <p:nvPr/>
+        </p:nvSpPr>
+        <p:spPr>
+          <a:xfrm>
+            <a:off x="9413748" y="4846320"/>
+            <a:ext cx="2125980" cy="822960"/>
+          </a:xfrm>
+          <a:prstGeom prst="rect">
+            <a:avLst/>
+          </a:prstGeom>
+          <a:solidFill>
+            <a:srgbClr val="FFFFFF"/>
+          </a:solidFill>
+          <a:ln w="9525">
+            <a:solidFill>
+              <a:srgbClr val="D8DDE6"/>
+            </a:solidFill>
+            <a:prstDash val="solid"/>
+          </a:ln>
+        </p:spPr>
+      </p:sp>
+      <p:sp>
+        <p:nvSpPr>
+          <p:cNvPr id="52" name="Text 50"/>
+          <p:cNvSpPr/>
+          <p:nvPr/>
+        </p:nvSpPr>
+        <p:spPr>
+          <a:xfrm>
+            <a:off x="9486900" y="4846320"/>
+            <a:ext cx="1979676" cy="822960"/>
+          </a:xfrm>
+          <a:prstGeom prst="rect">
+            <a:avLst/>
+          </a:prstGeom>
+          <a:noFill/>
+          <a:ln/>
+        </p:spPr>
+        <p:txBody>
+          <a:bodyPr wrap="square" lIns="0" tIns="0" rIns="0" bIns="0" rtlCol="0" anchor="ctr"/>
+          <a:lstStyle/>
+          <a:p>
+            <a:pPr algn="ctr" indent="0" marL="0">
+              <a:buNone/>
+            </a:pPr>
+            <a:r>
+              <a:rPr lang="en-US" sz="1150" dirty="0">
+                <a:solidFill>
+                  <a:srgbClr val="1F2A44"/>
+                </a:solidFill>
+                <a:latin typeface="맑은 고딕" pitchFamily="34" charset="0"/>
+                <a:ea typeface="맑은 고딕" pitchFamily="34" charset="-122"/>
+                <a:cs typeface="맑은 고딕" pitchFamily="34" charset="-120"/>
+              </a:rPr>
+              <a:t>86%</a:t>
+            </a:r>
+            <a:endParaRPr lang="en-US" sz="1150" dirty="0"/>
+          </a:p>
+        </p:txBody>
+      </p:sp>
+      <p:sp>
+        <p:nvSpPr>
+          <p:cNvPr id="53" name="Text 51"/>
+          <p:cNvSpPr/>
+          <p:nvPr/>
+        </p:nvSpPr>
+        <p:spPr>
+          <a:xfrm>
+            <a:off x="822960" y="6272784"/>
+            <a:ext cx="10515600" cy="182880"/>
+          </a:xfrm>
+          <a:prstGeom prst="rect">
+            <a:avLst/>
+          </a:prstGeom>
+          <a:noFill/>
+          <a:ln/>
+        </p:spPr>
+        <p:txBody>
+          <a:bodyPr wrap="square" lIns="0" tIns="0" rIns="0" bIns="0" rtlCol="0" anchor="ctr"/>
+          <a:lstStyle/>
+          <a:p>
+            <a:pPr algn="l" indent="0" marL="0">
+              <a:buNone/>
+            </a:pPr>
+            <a:r>
+              <a:rPr lang="en-US" sz="850" dirty="0">
+                <a:solidFill>
+                  <a:srgbClr val="8A93A4"/>
+                </a:solidFill>
+                <a:latin typeface="맑은 고딕" pitchFamily="34" charset="0"/>
+                <a:ea typeface="맑은 고딕" pitchFamily="34" charset="-122"/>
+                <a:cs typeface="맑은 고딕" pitchFamily="34" charset="-120"/>
+              </a:rPr>
+              <a:t>* 수치는 전건 가정(예시), 공시 자료 기준으로 대체 필요</a:t>
             </a:r>
             <a:endParaRPr lang="en-US" sz="850" dirty="0"/>
           </a:p>

</xml_diff>